<commit_message>
docs: update AI Autonomy Executive Deck
</commit_message>
<xml_diff>
--- a/projects/top-down-racer-02/docs/summary/AI-Autonomy-Executive-Deck.pptx
+++ b/projects/top-down-racer-02/docs/summary/AI-Autonomy-Executive-Deck.pptx
@@ -1843,94 +1843,7 @@
       </p:sp>
       <p:sp>
         <p:nvSpPr>
-          <p:cNvPr id="5" name="Shape 3"/>
-          <p:cNvSpPr/>
-          <p:nvPr/>
-        </p:nvSpPr>
-        <p:spPr>
-          <a:xfrm>
-            <a:off x="731520" y="3657600"/>
-            <a:ext cx="5029200" cy="502920"/>
-          </a:xfrm>
-          <a:prstGeom prst="roundRect">
-            <a:avLst>
-              <a:gd name="adj" fmla="val 14545"/>
-            </a:avLst>
-          </a:prstGeom>
-          <a:solidFill>
-            <a:srgbClr val="0D1B2A"/>
-          </a:solidFill>
-          <a:ln w="19050">
-            <a:solidFill>
-              <a:srgbClr val="00D4FF"/>
-            </a:solidFill>
-            <a:prstDash val="solid"/>
-          </a:ln>
-        </p:spPr>
-      </p:sp>
-      <p:sp>
-        <p:nvSpPr>
-          <p:cNvPr id="6" name="Text 4"/>
-          <p:cNvSpPr/>
-          <p:nvPr/>
-        </p:nvSpPr>
-        <p:spPr>
-          <a:xfrm>
-            <a:off x="914400" y="3703320"/>
-            <a:ext cx="4846320" cy="411480"/>
-          </a:xfrm>
-          <a:prstGeom prst="rect">
-            <a:avLst/>
-          </a:prstGeom>
-          <a:noFill/>
-          <a:ln/>
-        </p:spPr>
-        <p:txBody>
-          <a:bodyPr wrap="square" rtlCol="0" anchor="ctr"/>
-          <a:lstStyle/>
-          <a:p>
-            <a:pPr indent="0" marL="0">
-              <a:buNone/>
-            </a:pPr>
-            <a:r>
-              <a:rPr lang="en-US" sz="1300" b="1" spc="200" kern="0" dirty="0">
-                <a:solidFill>
-                  <a:srgbClr val="00D4FF"/>
-                </a:solidFill>
-                <a:latin typeface="Arial" pitchFamily="34" charset="0"/>
-                <a:ea typeface="Arial" pitchFamily="34" charset="-122"/>
-                <a:cs typeface="Arial" pitchFamily="34" charset="-120"/>
-              </a:rPr>
-              <a:t>PLAY IT NOW  </a:t>
-            </a:r>
-            <a:pPr indent="0" marL="0">
-              <a:buNone/>
-            </a:pPr>
-            <a:r>
-              <a:rPr lang="en-US" sz="1300" u="sng" dirty="0">
-                <a:solidFill>
-                  <a:srgbClr val="FFFFFF"/>
-                </a:solidFill>
-                <a:latin typeface="Consolas" pitchFamily="34" charset="0"/>
-                <a:ea typeface="Consolas" pitchFamily="34" charset="-122"/>
-                <a:cs typeface="Consolas" pitchFamily="34" charset="-120"/>
-                <a:hlinkClick r:id="rId1" invalidUrl="" action="" tgtFrame="" tooltip="" history="1" highlightClick="0" endSnd="0">
-                  <a:extLst>
-                    <a:ext uri="{A12FA001-AC4F-418D-AE19-62706E023703}">
-                      <ahyp:hlinkClr xmlns:ahyp="http://schemas.microsoft.com/office/drawing/2018/hyperlinkcolor" val="tx"/>
-                    </a:ext>
-                  </a:extLst>
-                </a:hlinkClick>
-              </a:rPr>
-              <a:t>https://top-down-racer-02.vercel.app/</a:t>
-            </a:r>
-            <a:endParaRPr lang="en-US" sz="1300" dirty="0"/>
-          </a:p>
-        </p:txBody>
-      </p:sp>
-      <p:sp>
-        <p:nvSpPr>
-          <p:cNvPr id="7" name="Text 5"/>
+          <p:cNvPr id="5" name="Text 3"/>
           <p:cNvSpPr/>
           <p:nvPr/>
         </p:nvSpPr>
@@ -2242,7 +2155,7 @@
                 <a:ea typeface="Arial Black" pitchFamily="34" charset="-122"/>
                 <a:cs typeface="Arial Black" pitchFamily="34" charset="-120"/>
               </a:rPr>
-              <a:t>80+</a:t>
+              <a:t>189+</a:t>
             </a:r>
             <a:endParaRPr lang="en-US" sz="2000" dirty="0"/>
           </a:p>
@@ -2557,7 +2470,7 @@
                 <a:ea typeface="Arial Black" pitchFamily="34" charset="-122"/>
                 <a:cs typeface="Arial Black" pitchFamily="34" charset="-120"/>
               </a:rPr>
-              <a:t>$0</a:t>
+              <a:t>10,497</a:t>
             </a:r>
             <a:endParaRPr lang="en-US" sz="2000" dirty="0"/>
           </a:p>
@@ -2596,7 +2509,7 @@
                 <a:ea typeface="Arial" pitchFamily="34" charset="-122"/>
                 <a:cs typeface="Arial" pitchFamily="34" charset="-120"/>
               </a:rPr>
-              <a:t>server cost</a:t>
+              <a:t>lines of code</a:t>
             </a:r>
             <a:endParaRPr lang="en-US" sz="900" dirty="0"/>
           </a:p>
@@ -2898,7 +2811,7 @@
                 <a:ea typeface="Arial" pitchFamily="34" charset="-122"/>
                 <a:cs typeface="Arial" pitchFamily="34" charset="-120"/>
               </a:rPr>
-              <a:t>THE CLAIM</a:t>
+              <a:t>WHAT WAS BUILT</a:t>
             </a:r>
             <a:endParaRPr lang="en-US" sz="1400" dirty="0"/>
           </a:p>
@@ -2906,148 +2819,14 @@
       </p:sp>
       <p:sp>
         <p:nvSpPr>
-          <p:cNvPr id="3" name="Text 1"/>
-          <p:cNvSpPr/>
-          <p:nvPr/>
-        </p:nvSpPr>
-        <p:spPr>
-          <a:xfrm>
-            <a:off x="731520" y="731520"/>
-            <a:ext cx="4572000" cy="2560320"/>
-          </a:xfrm>
-          <a:prstGeom prst="rect">
-            <a:avLst/>
-          </a:prstGeom>
-          <a:noFill/>
-          <a:ln/>
-        </p:spPr>
-        <p:txBody>
-          <a:bodyPr wrap="square" rtlCol="0" anchor="ctr"/>
-          <a:lstStyle/>
-          <a:p>
-            <a:pPr indent="0" marL="0">
-              <a:buNone/>
-            </a:pPr>
-            <a:r>
-              <a:rPr lang="en-US" sz="14400" b="1" dirty="0">
-                <a:solidFill>
-                  <a:srgbClr val="00D4FF"/>
-                </a:solidFill>
-                <a:latin typeface="Arial Black" pitchFamily="34" charset="0"/>
-                <a:ea typeface="Arial Black" pitchFamily="34" charset="-122"/>
-                <a:cs typeface="Arial Black" pitchFamily="34" charset="-120"/>
-              </a:rPr>
-              <a:t>0</a:t>
-            </a:r>
-            <a:endParaRPr lang="en-US" sz="14400" dirty="0"/>
-          </a:p>
-        </p:txBody>
-      </p:sp>
-      <p:sp>
-        <p:nvSpPr>
-          <p:cNvPr id="4" name="Text 2"/>
-          <p:cNvSpPr/>
-          <p:nvPr/>
-        </p:nvSpPr>
-        <p:spPr>
-          <a:xfrm>
-            <a:off x="731520" y="2926080"/>
-            <a:ext cx="4572000" cy="457200"/>
-          </a:xfrm>
-          <a:prstGeom prst="rect">
-            <a:avLst/>
-          </a:prstGeom>
-          <a:noFill/>
-          <a:ln/>
-        </p:spPr>
-        <p:txBody>
-          <a:bodyPr wrap="square" rtlCol="0" anchor="ctr"/>
-          <a:lstStyle/>
-          <a:p>
-            <a:pPr indent="0" marL="0">
-              <a:buNone/>
-            </a:pPr>
-            <a:r>
-              <a:rPr lang="en-US" sz="2000" b="1" dirty="0">
-                <a:solidFill>
-                  <a:srgbClr val="FFFFFF"/>
-                </a:solidFill>
-                <a:latin typeface="Arial" pitchFamily="34" charset="0"/>
-                <a:ea typeface="Arial" pitchFamily="34" charset="-122"/>
-                <a:cs typeface="Arial" pitchFamily="34" charset="-120"/>
-              </a:rPr>
-              <a:t>lines of hand-written game code</a:t>
-            </a:r>
-            <a:endParaRPr lang="en-US" sz="2000" dirty="0"/>
-          </a:p>
-        </p:txBody>
-      </p:sp>
-      <p:sp>
-        <p:nvSpPr>
-          <p:cNvPr id="5" name="Text 3"/>
-          <p:cNvSpPr/>
-          <p:nvPr/>
-        </p:nvSpPr>
-        <p:spPr>
-          <a:xfrm>
-            <a:off x="731520" y="3383280"/>
-            <a:ext cx="4572000" cy="548640"/>
-          </a:xfrm>
-          <a:prstGeom prst="rect">
-            <a:avLst/>
-          </a:prstGeom>
-          <a:noFill/>
-          <a:ln/>
-        </p:spPr>
-        <p:txBody>
-          <a:bodyPr wrap="square" rtlCol="0" anchor="ctr"/>
-          <a:lstStyle/>
-          <a:p>
-            <a:pPr indent="0" marL="0">
-              <a:buNone/>
-            </a:pPr>
-            <a:r>
-              <a:rPr lang="en-US" sz="1200" dirty="0">
-                <a:solidFill>
-                  <a:srgbClr val="8899AA"/>
-                </a:solidFill>
-                <a:latin typeface="Arial" pitchFamily="34" charset="0"/>
-                <a:ea typeface="Arial" pitchFamily="34" charset="-122"/>
-                <a:cs typeface="Arial" pitchFamily="34" charset="-120"/>
-              </a:rPr>
-              <a:t>Every line authored by Claude Code under human architectural direction.</a:t>
-            </a:r>
-            <a:endParaRPr lang="en-US" sz="1200" dirty="0"/>
-          </a:p>
-          <a:p>
-            <a:pPr indent="0" marL="0">
-              <a:buNone/>
-            </a:pPr>
-            <a:r>
-              <a:rPr lang="en-US" sz="1200" dirty="0">
-                <a:solidFill>
-                  <a:srgbClr val="8899AA"/>
-                </a:solidFill>
-                <a:latin typeface="Arial" pitchFamily="34" charset="0"/>
-                <a:ea typeface="Arial" pitchFamily="34" charset="-122"/>
-                <a:cs typeface="Arial" pitchFamily="34" charset="-120"/>
-              </a:rPr>
-              <a:t>Not copilot. Not autocomplete. Autonomous development.</a:t>
-            </a:r>
-            <a:endParaRPr lang="en-US" sz="1200" dirty="0"/>
-          </a:p>
-        </p:txBody>
-      </p:sp>
-      <p:sp>
-        <p:nvSpPr>
-          <p:cNvPr id="6" name="Shape 4"/>
-          <p:cNvSpPr/>
-          <p:nvPr/>
-        </p:nvSpPr>
-        <p:spPr>
-          <a:xfrm>
-            <a:off x="5669280" y="914400"/>
-            <a:ext cx="3017520" cy="594360"/>
+          <p:cNvPr id="3" name="Shape 1"/>
+          <p:cNvSpPr/>
+          <p:nvPr/>
+        </p:nvSpPr>
+        <p:spPr>
+          <a:xfrm>
+            <a:off x="457200" y="914400"/>
+            <a:ext cx="1965960" cy="2286000"/>
           </a:xfrm>
           <a:prstGeom prst="rect">
             <a:avLst/>
@@ -3067,14 +2846,34 @@
       </p:sp>
       <p:sp>
         <p:nvSpPr>
-          <p:cNvPr id="7" name="Text 5"/>
-          <p:cNvSpPr/>
-          <p:nvPr/>
-        </p:nvSpPr>
-        <p:spPr>
-          <a:xfrm>
-            <a:off x="5852160" y="960120"/>
-            <a:ext cx="1097280" cy="502920"/>
+          <p:cNvPr id="4" name="Shape 2"/>
+          <p:cNvSpPr/>
+          <p:nvPr/>
+        </p:nvSpPr>
+        <p:spPr>
+          <a:xfrm>
+            <a:off x="457200" y="914400"/>
+            <a:ext cx="1965960" cy="54864"/>
+          </a:xfrm>
+          <a:prstGeom prst="rect">
+            <a:avLst/>
+          </a:prstGeom>
+          <a:solidFill>
+            <a:srgbClr val="00D4FF"/>
+          </a:solidFill>
+          <a:ln/>
+        </p:spPr>
+      </p:sp>
+      <p:sp>
+        <p:nvSpPr>
+          <p:cNvPr id="5" name="Text 3"/>
+          <p:cNvSpPr/>
+          <p:nvPr/>
+        </p:nvSpPr>
+        <p:spPr>
+          <a:xfrm>
+            <a:off x="594360" y="1097280"/>
+            <a:ext cx="1691640" cy="411480"/>
           </a:xfrm>
           <a:prstGeom prst="rect">
             <a:avLst/>
@@ -3090,30 +2889,30 @@
               <a:buNone/>
             </a:pPr>
             <a:r>
-              <a:rPr lang="en-US" sz="2200" b="1" dirty="0">
-                <a:solidFill>
-                  <a:srgbClr val="00D4FF"/>
-                </a:solidFill>
-                <a:latin typeface="Arial Black" pitchFamily="34" charset="0"/>
-                <a:ea typeface="Arial Black" pitchFamily="34" charset="-122"/>
-                <a:cs typeface="Arial Black" pitchFamily="34" charset="-120"/>
-              </a:rPr>
-              <a:t>6 of 6</a:t>
-            </a:r>
-            <a:endParaRPr lang="en-US" sz="2200" dirty="0"/>
-          </a:p>
-        </p:txBody>
-      </p:sp>
-      <p:sp>
-        <p:nvSpPr>
-          <p:cNvPr id="8" name="Text 6"/>
-          <p:cNvSpPr/>
-          <p:nvPr/>
-        </p:nvSpPr>
-        <p:spPr>
-          <a:xfrm>
-            <a:off x="6949440" y="960120"/>
-            <a:ext cx="1645920" cy="502920"/>
+              <a:rPr lang="en-US" sz="1500" b="1" dirty="0">
+                <a:solidFill>
+                  <a:srgbClr val="FFFFFF"/>
+                </a:solidFill>
+                <a:latin typeface="Arial" pitchFamily="34" charset="0"/>
+                <a:ea typeface="Arial" pitchFamily="34" charset="-122"/>
+                <a:cs typeface="Arial" pitchFamily="34" charset="-120"/>
+              </a:rPr>
+              <a:t>Racing Game</a:t>
+            </a:r>
+            <a:endParaRPr lang="en-US" sz="1500" dirty="0"/>
+          </a:p>
+        </p:txBody>
+      </p:sp>
+      <p:sp>
+        <p:nvSpPr>
+          <p:cNvPr id="6" name="Text 4"/>
+          <p:cNvSpPr/>
+          <p:nvPr/>
+        </p:nvSpPr>
+        <p:spPr>
+          <a:xfrm>
+            <a:off x="594360" y="1554480"/>
+            <a:ext cx="1691640" cy="1371600"/>
           </a:xfrm>
           <a:prstGeom prst="rect">
             <a:avLst/>
@@ -3129,7 +2928,7 @@
               <a:buNone/>
             </a:pPr>
             <a:r>
-              <a:rPr lang="en-US" sz="1200" dirty="0">
+              <a:rPr lang="en-US" sz="1100" dirty="0">
                 <a:solidFill>
                   <a:srgbClr val="8899AA"/>
                 </a:solidFill>
@@ -3137,22 +2936,39 @@
                 <a:ea typeface="Arial" pitchFamily="34" charset="-122"/>
                 <a:cs typeface="Arial" pitchFamily="34" charset="-120"/>
               </a:rPr>
-              <a:t>Phases completed</a:t>
-            </a:r>
-            <a:endParaRPr lang="en-US" sz="1200" dirty="0"/>
-          </a:p>
-        </p:txBody>
-      </p:sp>
-      <p:sp>
-        <p:nvSpPr>
-          <p:cNvPr id="9" name="Shape 7"/>
-          <p:cNvSpPr/>
-          <p:nvPr/>
-        </p:nvSpPr>
-        <p:spPr>
-          <a:xfrm>
-            <a:off x="5669280" y="1627632"/>
-            <a:ext cx="3017520" cy="594360"/>
+              <a:t>3 tracks, full sound, particles,</a:t>
+            </a:r>
+            <a:endParaRPr lang="en-US" sz="1100" dirty="0"/>
+          </a:p>
+          <a:p>
+            <a:pPr indent="0" marL="0">
+              <a:buNone/>
+            </a:pPr>
+            <a:r>
+              <a:rPr lang="en-US" sz="1100" dirty="0">
+                <a:solidFill>
+                  <a:srgbClr val="8899AA"/>
+                </a:solidFill>
+                <a:latin typeface="Arial" pitchFamily="34" charset="0"/>
+                <a:ea typeface="Arial" pitchFamily="34" charset="-122"/>
+                <a:cs typeface="Arial" pitchFamily="34" charset="-120"/>
+              </a:rPr>
+              <a:t>menus, HUD, pause, replays</a:t>
+            </a:r>
+            <a:endParaRPr lang="en-US" sz="1100" dirty="0"/>
+          </a:p>
+        </p:txBody>
+      </p:sp>
+      <p:sp>
+        <p:nvSpPr>
+          <p:cNvPr id="7" name="Shape 5"/>
+          <p:cNvSpPr/>
+          <p:nvPr/>
+        </p:nvSpPr>
+        <p:spPr>
+          <a:xfrm>
+            <a:off x="2606040" y="914400"/>
+            <a:ext cx="1965960" cy="2286000"/>
           </a:xfrm>
           <a:prstGeom prst="rect">
             <a:avLst/>
@@ -3172,14 +2988,73 @@
       </p:sp>
       <p:sp>
         <p:nvSpPr>
+          <p:cNvPr id="8" name="Shape 6"/>
+          <p:cNvSpPr/>
+          <p:nvPr/>
+        </p:nvSpPr>
+        <p:spPr>
+          <a:xfrm>
+            <a:off x="2606040" y="914400"/>
+            <a:ext cx="1965960" cy="54864"/>
+          </a:xfrm>
+          <a:prstGeom prst="rect">
+            <a:avLst/>
+          </a:prstGeom>
+          <a:solidFill>
+            <a:srgbClr val="00FF88"/>
+          </a:solidFill>
+          <a:ln/>
+        </p:spPr>
+      </p:sp>
+      <p:sp>
+        <p:nvSpPr>
+          <p:cNvPr id="9" name="Text 7"/>
+          <p:cNvSpPr/>
+          <p:nvPr/>
+        </p:nvSpPr>
+        <p:spPr>
+          <a:xfrm>
+            <a:off x="2743200" y="1097280"/>
+            <a:ext cx="1691640" cy="411480"/>
+          </a:xfrm>
+          <a:prstGeom prst="rect">
+            <a:avLst/>
+          </a:prstGeom>
+          <a:noFill/>
+          <a:ln/>
+        </p:spPr>
+        <p:txBody>
+          <a:bodyPr wrap="square" rtlCol="0" anchor="ctr"/>
+          <a:lstStyle/>
+          <a:p>
+            <a:pPr indent="0" marL="0">
+              <a:buNone/>
+            </a:pPr>
+            <a:r>
+              <a:rPr lang="en-US" sz="1500" b="1" dirty="0">
+                <a:solidFill>
+                  <a:srgbClr val="FFFFFF"/>
+                </a:solidFill>
+                <a:latin typeface="Arial" pitchFamily="34" charset="0"/>
+                <a:ea typeface="Arial" pitchFamily="34" charset="-122"/>
+                <a:cs typeface="Arial" pitchFamily="34" charset="-120"/>
+              </a:rPr>
+              <a:t>Neural Network AI</a:t>
+            </a:r>
+            <a:endParaRPr lang="en-US" sz="1500" dirty="0"/>
+          </a:p>
+        </p:txBody>
+      </p:sp>
+      <p:sp>
+        <p:nvSpPr>
           <p:cNvPr id="10" name="Text 8"/>
           <p:cNvSpPr/>
           <p:nvPr/>
         </p:nvSpPr>
         <p:spPr>
           <a:xfrm>
-            <a:off x="5852160" y="1673352"/>
-            <a:ext cx="1097280" cy="502920"/>
+            <a:off x="2743200" y="1554480"/>
+            <a:ext cx="1691640" cy="1371600"/>
           </a:xfrm>
           <a:prstGeom prst="rect">
             <a:avLst/>
@@ -3195,46 +3070,24 @@
               <a:buNone/>
             </a:pPr>
             <a:r>
-              <a:rPr lang="en-US" sz="2200" b="1" dirty="0">
-                <a:solidFill>
-                  <a:srgbClr val="00D4FF"/>
-                </a:solidFill>
-                <a:latin typeface="Arial Black" pitchFamily="34" charset="0"/>
-                <a:ea typeface="Arial Black" pitchFamily="34" charset="-122"/>
-                <a:cs typeface="Arial Black" pitchFamily="34" charset="-120"/>
-              </a:rPr>
-              <a:t>80+</a:t>
-            </a:r>
-            <a:endParaRPr lang="en-US" sz="2200" dirty="0"/>
-          </a:p>
-        </p:txBody>
-      </p:sp>
-      <p:sp>
-        <p:nvSpPr>
-          <p:cNvPr id="11" name="Text 9"/>
-          <p:cNvSpPr/>
-          <p:nvPr/>
-        </p:nvSpPr>
-        <p:spPr>
-          <a:xfrm>
-            <a:off x="6949440" y="1673352"/>
-            <a:ext cx="1645920" cy="502920"/>
-          </a:xfrm>
-          <a:prstGeom prst="rect">
-            <a:avLst/>
-          </a:prstGeom>
-          <a:noFill/>
-          <a:ln/>
-        </p:spPr>
-        <p:txBody>
-          <a:bodyPr wrap="square" rtlCol="0" anchor="ctr"/>
-          <a:lstStyle/>
+              <a:rPr lang="en-US" sz="1100" dirty="0">
+                <a:solidFill>
+                  <a:srgbClr val="8899AA"/>
+                </a:solidFill>
+                <a:latin typeface="Arial" pitchFamily="34" charset="0"/>
+                <a:ea typeface="Arial" pitchFamily="34" charset="-122"/>
+                <a:cs typeface="Arial" pitchFamily="34" charset="-120"/>
+              </a:rPr>
+              <a:t>Self-taught driving via RL —</a:t>
+            </a:r>
+            <a:endParaRPr lang="en-US" sz="1100" dirty="0"/>
+          </a:p>
           <a:p>
             <a:pPr indent="0" marL="0">
               <a:buNone/>
             </a:pPr>
             <a:r>
-              <a:rPr lang="en-US" sz="1200" dirty="0">
+              <a:rPr lang="en-US" sz="1100" dirty="0">
                 <a:solidFill>
                   <a:srgbClr val="8899AA"/>
                 </a:solidFill>
@@ -3242,22 +3095,22 @@
                 <a:ea typeface="Arial" pitchFamily="34" charset="-122"/>
                 <a:cs typeface="Arial" pitchFamily="34" charset="-120"/>
               </a:rPr>
-              <a:t>Git commits</a:t>
-            </a:r>
-            <a:endParaRPr lang="en-US" sz="1200" dirty="0"/>
-          </a:p>
-        </p:txBody>
-      </p:sp>
-      <p:sp>
-        <p:nvSpPr>
-          <p:cNvPr id="12" name="Shape 10"/>
-          <p:cNvSpPr/>
-          <p:nvPr/>
-        </p:nvSpPr>
-        <p:spPr>
-          <a:xfrm>
-            <a:off x="5669280" y="2340864"/>
-            <a:ext cx="3017520" cy="594360"/>
+              <a:t>zero human training data</a:t>
+            </a:r>
+            <a:endParaRPr lang="en-US" sz="1100" dirty="0"/>
+          </a:p>
+        </p:txBody>
+      </p:sp>
+      <p:sp>
+        <p:nvSpPr>
+          <p:cNvPr id="11" name="Shape 9"/>
+          <p:cNvSpPr/>
+          <p:nvPr/>
+        </p:nvSpPr>
+        <p:spPr>
+          <a:xfrm>
+            <a:off x="4754880" y="914400"/>
+            <a:ext cx="1965960" cy="2286000"/>
           </a:xfrm>
           <a:prstGeom prst="rect">
             <a:avLst/>
@@ -3277,14 +3130,34 @@
       </p:sp>
       <p:sp>
         <p:nvSpPr>
+          <p:cNvPr id="12" name="Shape 10"/>
+          <p:cNvSpPr/>
+          <p:nvPr/>
+        </p:nvSpPr>
+        <p:spPr>
+          <a:xfrm>
+            <a:off x="4754880" y="914400"/>
+            <a:ext cx="1965960" cy="54864"/>
+          </a:xfrm>
+          <a:prstGeom prst="rect">
+            <a:avLst/>
+          </a:prstGeom>
+          <a:solidFill>
+            <a:srgbClr val="FFB800"/>
+          </a:solidFill>
+          <a:ln/>
+        </p:spPr>
+      </p:sp>
+      <p:sp>
+        <p:nvSpPr>
           <p:cNvPr id="13" name="Text 11"/>
           <p:cNvSpPr/>
           <p:nvPr/>
         </p:nvSpPr>
         <p:spPr>
           <a:xfrm>
-            <a:off x="5852160" y="2386584"/>
-            <a:ext cx="1097280" cy="502920"/>
+            <a:off x="4892040" y="1097280"/>
+            <a:ext cx="1691640" cy="411480"/>
           </a:xfrm>
           <a:prstGeom prst="rect">
             <a:avLst/>
@@ -3300,17 +3173,17 @@
               <a:buNone/>
             </a:pPr>
             <a:r>
-              <a:rPr lang="en-US" sz="2200" b="1" dirty="0">
-                <a:solidFill>
-                  <a:srgbClr val="00D4FF"/>
-                </a:solidFill>
-                <a:latin typeface="Arial Black" pitchFamily="34" charset="0"/>
-                <a:ea typeface="Arial Black" pitchFamily="34" charset="-122"/>
-                <a:cs typeface="Arial Black" pitchFamily="34" charset="-120"/>
-              </a:rPr>
-              <a:t>389+</a:t>
-            </a:r>
-            <a:endParaRPr lang="en-US" sz="2200" dirty="0"/>
+              <a:rPr lang="en-US" sz="1500" b="1" dirty="0">
+                <a:solidFill>
+                  <a:srgbClr val="FFFFFF"/>
+                </a:solidFill>
+                <a:latin typeface="Arial" pitchFamily="34" charset="0"/>
+                <a:ea typeface="Arial" pitchFamily="34" charset="-122"/>
+                <a:cs typeface="Arial" pitchFamily="34" charset="-120"/>
+              </a:rPr>
+              <a:t>Browser Deployed</a:t>
+            </a:r>
+            <a:endParaRPr lang="en-US" sz="1500" dirty="0"/>
           </a:p>
         </p:txBody>
       </p:sp>
@@ -3322,8 +3195,8 @@
         </p:nvSpPr>
         <p:spPr>
           <a:xfrm>
-            <a:off x="6949440" y="2386584"/>
-            <a:ext cx="1645920" cy="502920"/>
+            <a:off x="4892040" y="1554480"/>
+            <a:ext cx="1691640" cy="1371600"/>
           </a:xfrm>
           <a:prstGeom prst="rect">
             <a:avLst/>
@@ -3339,7 +3212,7 @@
               <a:buNone/>
             </a:pPr>
             <a:r>
-              <a:rPr lang="en-US" sz="1200" dirty="0">
+              <a:rPr lang="en-US" sz="1100" dirty="0">
                 <a:solidFill>
                   <a:srgbClr val="8899AA"/>
                 </a:solidFill>
@@ -3347,9 +3220,26 @@
                 <a:ea typeface="Arial" pitchFamily="34" charset="-122"/>
                 <a:cs typeface="Arial" pitchFamily="34" charset="-120"/>
               </a:rPr>
-              <a:t>Automated tests</a:t>
-            </a:r>
-            <a:endParaRPr lang="en-US" sz="1200" dirty="0"/>
+              <a:t>ONNX inference at 60fps,</a:t>
+            </a:r>
+            <a:endParaRPr lang="en-US" sz="1100" dirty="0"/>
+          </a:p>
+          <a:p>
+            <a:pPr indent="0" marL="0">
+              <a:buNone/>
+            </a:pPr>
+            <a:r>
+              <a:rPr lang="en-US" sz="1100" dirty="0">
+                <a:solidFill>
+                  <a:srgbClr val="8899AA"/>
+                </a:solidFill>
+                <a:latin typeface="Arial" pitchFamily="34" charset="0"/>
+                <a:ea typeface="Arial" pitchFamily="34" charset="-122"/>
+                <a:cs typeface="Arial" pitchFamily="34" charset="-120"/>
+              </a:rPr>
+              <a:t>fully static, zero server</a:t>
+            </a:r>
+            <a:endParaRPr lang="en-US" sz="1100" dirty="0"/>
           </a:p>
         </p:txBody>
       </p:sp>
@@ -3361,8 +3251,8 @@
         </p:nvSpPr>
         <p:spPr>
           <a:xfrm>
-            <a:off x="5669280" y="3054096"/>
-            <a:ext cx="3017520" cy="594360"/>
+            <a:off x="6903720" y="914400"/>
+            <a:ext cx="1965960" cy="2286000"/>
           </a:xfrm>
           <a:prstGeom prst="rect">
             <a:avLst/>
@@ -3382,14 +3272,34 @@
       </p:sp>
       <p:sp>
         <p:nvSpPr>
-          <p:cNvPr id="16" name="Text 14"/>
-          <p:cNvSpPr/>
-          <p:nvPr/>
-        </p:nvSpPr>
-        <p:spPr>
-          <a:xfrm>
-            <a:off x="5852160" y="3099816"/>
-            <a:ext cx="1097280" cy="502920"/>
+          <p:cNvPr id="16" name="Shape 14"/>
+          <p:cNvSpPr/>
+          <p:nvPr/>
+        </p:nvSpPr>
+        <p:spPr>
+          <a:xfrm>
+            <a:off x="6903720" y="914400"/>
+            <a:ext cx="1965960" cy="54864"/>
+          </a:xfrm>
+          <a:prstGeom prst="rect">
+            <a:avLst/>
+          </a:prstGeom>
+          <a:solidFill>
+            <a:srgbClr val="A78BFA"/>
+          </a:solidFill>
+          <a:ln/>
+        </p:spPr>
+      </p:sp>
+      <p:sp>
+        <p:nvSpPr>
+          <p:cNvPr id="17" name="Text 15"/>
+          <p:cNvSpPr/>
+          <p:nvPr/>
+        </p:nvSpPr>
+        <p:spPr>
+          <a:xfrm>
+            <a:off x="7040880" y="1097280"/>
+            <a:ext cx="1691640" cy="411480"/>
           </a:xfrm>
           <a:prstGeom prst="rect">
             <a:avLst/>
@@ -3405,54 +3315,158 @@
               <a:buNone/>
             </a:pPr>
             <a:r>
-              <a:rPr lang="en-US" sz="2200" b="1" dirty="0">
+              <a:rPr lang="en-US" sz="1500" b="1" dirty="0">
+                <a:solidFill>
+                  <a:srgbClr val="FFFFFF"/>
+                </a:solidFill>
+                <a:latin typeface="Arial" pitchFamily="34" charset="0"/>
+                <a:ea typeface="Arial" pitchFamily="34" charset="-122"/>
+                <a:cs typeface="Arial" pitchFamily="34" charset="-120"/>
+              </a:rPr>
+              <a:t>AI vs Human</a:t>
+            </a:r>
+            <a:endParaRPr lang="en-US" sz="1500" dirty="0"/>
+          </a:p>
+        </p:txBody>
+      </p:sp>
+      <p:sp>
+        <p:nvSpPr>
+          <p:cNvPr id="18" name="Text 16"/>
+          <p:cNvSpPr/>
+          <p:nvPr/>
+        </p:nvSpPr>
+        <p:spPr>
+          <a:xfrm>
+            <a:off x="7040880" y="1554480"/>
+            <a:ext cx="1691640" cy="1371600"/>
+          </a:xfrm>
+          <a:prstGeom prst="rect">
+            <a:avLst/>
+          </a:prstGeom>
+          <a:noFill/>
+          <a:ln/>
+        </p:spPr>
+        <p:txBody>
+          <a:bodyPr wrap="square" rtlCol="0" anchor="ctr"/>
+          <a:lstStyle/>
+          <a:p>
+            <a:pPr indent="0" marL="0">
+              <a:buNone/>
+            </a:pPr>
+            <a:r>
+              <a:rPr lang="en-US" sz="1100" dirty="0">
+                <a:solidFill>
+                  <a:srgbClr val="8899AA"/>
+                </a:solidFill>
+                <a:latin typeface="Arial" pitchFamily="34" charset="0"/>
+                <a:ea typeface="Arial" pitchFamily="34" charset="-122"/>
+                <a:cs typeface="Arial" pitchFamily="34" charset="-120"/>
+              </a:rPr>
+              <a:t>Race against your own creation.</a:t>
+            </a:r>
+            <a:endParaRPr lang="en-US" sz="1100" dirty="0"/>
+          </a:p>
+          <a:p>
+            <a:pPr indent="0" marL="0">
+              <a:buNone/>
+            </a:pPr>
+            <a:r>
+              <a:rPr lang="en-US" sz="1100" dirty="0">
+                <a:solidFill>
+                  <a:srgbClr val="8899AA"/>
+                </a:solidFill>
+                <a:latin typeface="Arial" pitchFamily="34" charset="0"/>
+                <a:ea typeface="Arial" pitchFamily="34" charset="-122"/>
+                <a:cs typeface="Arial" pitchFamily="34" charset="-120"/>
+              </a:rPr>
+              <a:t>Head-to-head with grace period.</a:t>
+            </a:r>
+            <a:endParaRPr lang="en-US" sz="1100" dirty="0"/>
+          </a:p>
+        </p:txBody>
+      </p:sp>
+      <p:sp>
+        <p:nvSpPr>
+          <p:cNvPr id="19" name="Shape 17"/>
+          <p:cNvSpPr/>
+          <p:nvPr/>
+        </p:nvSpPr>
+        <p:spPr>
+          <a:xfrm>
+            <a:off x="731520" y="3566160"/>
+            <a:ext cx="7680960" cy="502920"/>
+          </a:xfrm>
+          <a:prstGeom prst="roundRect">
+            <a:avLst>
+              <a:gd name="adj" fmla="val 14545"/>
+            </a:avLst>
+          </a:prstGeom>
+          <a:solidFill>
+            <a:srgbClr val="0D1B2A"/>
+          </a:solidFill>
+          <a:ln w="12700">
+            <a:solidFill>
+              <a:srgbClr val="00D4FF"/>
+            </a:solidFill>
+            <a:prstDash val="solid"/>
+          </a:ln>
+        </p:spPr>
+      </p:sp>
+      <p:sp>
+        <p:nvSpPr>
+          <p:cNvPr id="20" name="Text 18"/>
+          <p:cNvSpPr/>
+          <p:nvPr/>
+        </p:nvSpPr>
+        <p:spPr>
+          <a:xfrm>
+            <a:off x="914400" y="3611880"/>
+            <a:ext cx="7315200" cy="411480"/>
+          </a:xfrm>
+          <a:prstGeom prst="rect">
+            <a:avLst/>
+          </a:prstGeom>
+          <a:noFill/>
+          <a:ln/>
+        </p:spPr>
+        <p:txBody>
+          <a:bodyPr wrap="square" rtlCol="0" anchor="ctr"/>
+          <a:lstStyle/>
+          <a:p>
+            <a:pPr algn="ctr" indent="0" marL="0">
+              <a:buNone/>
+            </a:pPr>
+            <a:r>
+              <a:rPr lang="en-US" sz="1200" b="1" dirty="0">
                 <a:solidFill>
                   <a:srgbClr val="00D4FF"/>
                 </a:solidFill>
-                <a:latin typeface="Arial Black" pitchFamily="34" charset="0"/>
-                <a:ea typeface="Arial Black" pitchFamily="34" charset="-122"/>
-                <a:cs typeface="Arial Black" pitchFamily="34" charset="-120"/>
-              </a:rPr>
-              <a:t>~3</a:t>
-            </a:r>
-            <a:endParaRPr lang="en-US" sz="2200" dirty="0"/>
-          </a:p>
-        </p:txBody>
-      </p:sp>
-      <p:sp>
-        <p:nvSpPr>
-          <p:cNvPr id="17" name="Text 15"/>
-          <p:cNvSpPr/>
-          <p:nvPr/>
-        </p:nvSpPr>
-        <p:spPr>
-          <a:xfrm>
-            <a:off x="6949440" y="3099816"/>
-            <a:ext cx="1645920" cy="502920"/>
-          </a:xfrm>
-          <a:prstGeom prst="rect">
-            <a:avLst/>
-          </a:prstGeom>
-          <a:noFill/>
-          <a:ln/>
-        </p:spPr>
-        <p:txBody>
-          <a:bodyPr wrap="square" rtlCol="0" anchor="ctr"/>
-          <a:lstStyle/>
-          <a:p>
-            <a:pPr indent="0" marL="0">
-              <a:buNone/>
-            </a:pPr>
-            <a:r>
-              <a:rPr lang="en-US" sz="1200" dirty="0">
-                <a:solidFill>
-                  <a:srgbClr val="8899AA"/>
-                </a:solidFill>
-                <a:latin typeface="Arial" pitchFamily="34" charset="0"/>
-                <a:ea typeface="Arial" pitchFamily="34" charset="-122"/>
-                <a:cs typeface="Arial" pitchFamily="34" charset="-120"/>
-              </a:rPr>
-              <a:t>Build days</a:t>
+                <a:latin typeface="Arial" pitchFamily="34" charset="0"/>
+                <a:ea typeface="Arial" pitchFamily="34" charset="-122"/>
+                <a:cs typeface="Arial" pitchFamily="34" charset="-120"/>
+              </a:rPr>
+              <a:t>PLAY IT LIVE  →  </a:t>
+            </a:r>
+            <a:pPr algn="ctr" indent="0" marL="0">
+              <a:buNone/>
+            </a:pPr>
+            <a:r>
+              <a:rPr lang="en-US" sz="1200" u="sng" dirty="0">
+                <a:solidFill>
+                  <a:srgbClr val="FFFFFF"/>
+                </a:solidFill>
+                <a:latin typeface="Consolas" pitchFamily="34" charset="0"/>
+                <a:ea typeface="Consolas" pitchFamily="34" charset="-122"/>
+                <a:cs typeface="Consolas" pitchFamily="34" charset="-120"/>
+                <a:hlinkClick r:id="rId1" invalidUrl="" action="" tgtFrame="" tooltip="" history="1" highlightClick="0" endSnd="0">
+                  <a:extLst>
+                    <a:ext uri="{A12FA001-AC4F-418D-AE19-62706E023703}">
+                      <ahyp:hlinkClr xmlns:ahyp="http://schemas.microsoft.com/office/drawing/2018/hyperlinkcolor" val="tx"/>
+                    </a:ext>
+                  </a:extLst>
+                </a:hlinkClick>
+              </a:rPr>
+              <a:t>https://top-down-racer-02.vercel.app/</a:t>
             </a:r>
             <a:endParaRPr lang="en-US" sz="1200" dirty="0"/>
           </a:p>
@@ -3460,106 +3474,40 @@
       </p:sp>
       <p:sp>
         <p:nvSpPr>
-          <p:cNvPr id="18" name="Shape 16"/>
-          <p:cNvSpPr/>
-          <p:nvPr/>
-        </p:nvSpPr>
-        <p:spPr>
-          <a:xfrm>
-            <a:off x="5669280" y="3767328"/>
-            <a:ext cx="3017520" cy="594360"/>
-          </a:xfrm>
-          <a:prstGeom prst="rect">
-            <a:avLst/>
-          </a:prstGeom>
-          <a:solidFill>
-            <a:srgbClr val="141929"/>
-          </a:solidFill>
-          <a:ln/>
-          <a:effectLst>
-            <a:outerShdw sx="100000" sy="100000" kx="0" ky="0" algn="bl" rotWithShape="0" blurRad="101600" dist="38100" dir="8100000">
-              <a:srgbClr val="000000">
-                <a:alpha val="40000"/>
-              </a:srgbClr>
-            </a:outerShdw>
-          </a:effectLst>
-        </p:spPr>
-      </p:sp>
-      <p:sp>
-        <p:nvSpPr>
-          <p:cNvPr id="19" name="Text 17"/>
-          <p:cNvSpPr/>
-          <p:nvPr/>
-        </p:nvSpPr>
-        <p:spPr>
-          <a:xfrm>
-            <a:off x="5852160" y="3813048"/>
-            <a:ext cx="1097280" cy="502920"/>
-          </a:xfrm>
-          <a:prstGeom prst="rect">
-            <a:avLst/>
-          </a:prstGeom>
-          <a:noFill/>
-          <a:ln/>
-        </p:spPr>
-        <p:txBody>
-          <a:bodyPr wrap="square" rtlCol="0" anchor="ctr"/>
-          <a:lstStyle/>
-          <a:p>
-            <a:pPr indent="0" marL="0">
-              <a:buNone/>
-            </a:pPr>
-            <a:r>
-              <a:rPr lang="en-US" sz="2200" b="1" dirty="0">
+          <p:cNvPr id="21" name="Text 19"/>
+          <p:cNvSpPr/>
+          <p:nvPr/>
+        </p:nvSpPr>
+        <p:spPr>
+          <a:xfrm>
+            <a:off x="731520" y="4297680"/>
+            <a:ext cx="7680960" cy="365760"/>
+          </a:xfrm>
+          <a:prstGeom prst="rect">
+            <a:avLst/>
+          </a:prstGeom>
+          <a:noFill/>
+          <a:ln/>
+        </p:spPr>
+        <p:txBody>
+          <a:bodyPr wrap="square" rtlCol="0" anchor="ctr"/>
+          <a:lstStyle/>
+          <a:p>
+            <a:pPr algn="ctr" indent="0" marL="0">
+              <a:buNone/>
+            </a:pPr>
+            <a:r>
+              <a:rPr lang="en-US" sz="1300" i="1" dirty="0">
                 <a:solidFill>
                   <a:srgbClr val="00D4FF"/>
                 </a:solidFill>
-                <a:latin typeface="Arial Black" pitchFamily="34" charset="0"/>
-                <a:ea typeface="Arial Black" pitchFamily="34" charset="-122"/>
-                <a:cs typeface="Arial Black" pitchFamily="34" charset="-120"/>
-              </a:rPr>
-              <a:t>$0</a:t>
-            </a:r>
-            <a:endParaRPr lang="en-US" sz="2200" dirty="0"/>
-          </a:p>
-        </p:txBody>
-      </p:sp>
-      <p:sp>
-        <p:nvSpPr>
-          <p:cNvPr id="20" name="Text 18"/>
-          <p:cNvSpPr/>
-          <p:nvPr/>
-        </p:nvSpPr>
-        <p:spPr>
-          <a:xfrm>
-            <a:off x="6949440" y="3813048"/>
-            <a:ext cx="1645920" cy="502920"/>
-          </a:xfrm>
-          <a:prstGeom prst="rect">
-            <a:avLst/>
-          </a:prstGeom>
-          <a:noFill/>
-          <a:ln/>
-        </p:spPr>
-        <p:txBody>
-          <a:bodyPr wrap="square" rtlCol="0" anchor="ctr"/>
-          <a:lstStyle/>
-          <a:p>
-            <a:pPr indent="0" marL="0">
-              <a:buNone/>
-            </a:pPr>
-            <a:r>
-              <a:rPr lang="en-US" sz="1200" dirty="0">
-                <a:solidFill>
-                  <a:srgbClr val="8899AA"/>
-                </a:solidFill>
-                <a:latin typeface="Arial" pitchFamily="34" charset="0"/>
-                <a:ea typeface="Arial" pitchFamily="34" charset="-122"/>
-                <a:cs typeface="Arial" pitchFamily="34" charset="-120"/>
-              </a:rPr>
-              <a:t>Server cost</a:t>
-            </a:r>
-            <a:endParaRPr lang="en-US" sz="1200" dirty="0"/>
+                <a:latin typeface="Arial" pitchFamily="34" charset="0"/>
+                <a:ea typeface="Arial" pitchFamily="34" charset="-122"/>
+                <a:cs typeface="Arial" pitchFamily="34" charset="-120"/>
+              </a:rPr>
+              <a:t>The human never writes code. The human makes decisions.</a:t>
+            </a:r>
+            <a:endParaRPr lang="en-US" sz="1300" dirty="0"/>
           </a:p>
         </p:txBody>
       </p:sp>
@@ -3628,7 +3576,7 @@
                 <a:ea typeface="Arial" pitchFamily="34" charset="-122"/>
                 <a:cs typeface="Arial" pitchFamily="34" charset="-120"/>
               </a:rPr>
-              <a:t>WHAT WAS BUILT</a:t>
+              <a:t>THE CLAIM</a:t>
             </a:r>
             <a:endParaRPr lang="en-US" sz="1400" dirty="0"/>
           </a:p>
@@ -3636,14 +3584,148 @@
       </p:sp>
       <p:sp>
         <p:nvSpPr>
-          <p:cNvPr id="3" name="Shape 1"/>
-          <p:cNvSpPr/>
-          <p:nvPr/>
-        </p:nvSpPr>
-        <p:spPr>
-          <a:xfrm>
-            <a:off x="457200" y="914400"/>
-            <a:ext cx="1965960" cy="2286000"/>
+          <p:cNvPr id="3" name="Text 1"/>
+          <p:cNvSpPr/>
+          <p:nvPr/>
+        </p:nvSpPr>
+        <p:spPr>
+          <a:xfrm>
+            <a:off x="731520" y="731520"/>
+            <a:ext cx="4572000" cy="2560320"/>
+          </a:xfrm>
+          <a:prstGeom prst="rect">
+            <a:avLst/>
+          </a:prstGeom>
+          <a:noFill/>
+          <a:ln/>
+        </p:spPr>
+        <p:txBody>
+          <a:bodyPr wrap="square" rtlCol="0" anchor="ctr"/>
+          <a:lstStyle/>
+          <a:p>
+            <a:pPr indent="0" marL="0">
+              <a:buNone/>
+            </a:pPr>
+            <a:r>
+              <a:rPr lang="en-US" sz="14400" b="1" dirty="0">
+                <a:solidFill>
+                  <a:srgbClr val="00D4FF"/>
+                </a:solidFill>
+                <a:latin typeface="Arial Black" pitchFamily="34" charset="0"/>
+                <a:ea typeface="Arial Black" pitchFamily="34" charset="-122"/>
+                <a:cs typeface="Arial Black" pitchFamily="34" charset="-120"/>
+              </a:rPr>
+              <a:t>0</a:t>
+            </a:r>
+            <a:endParaRPr lang="en-US" sz="14400" dirty="0"/>
+          </a:p>
+        </p:txBody>
+      </p:sp>
+      <p:sp>
+        <p:nvSpPr>
+          <p:cNvPr id="4" name="Text 2"/>
+          <p:cNvSpPr/>
+          <p:nvPr/>
+        </p:nvSpPr>
+        <p:spPr>
+          <a:xfrm>
+            <a:off x="731520" y="2926080"/>
+            <a:ext cx="4572000" cy="457200"/>
+          </a:xfrm>
+          <a:prstGeom prst="rect">
+            <a:avLst/>
+          </a:prstGeom>
+          <a:noFill/>
+          <a:ln/>
+        </p:spPr>
+        <p:txBody>
+          <a:bodyPr wrap="square" rtlCol="0" anchor="ctr"/>
+          <a:lstStyle/>
+          <a:p>
+            <a:pPr indent="0" marL="0">
+              <a:buNone/>
+            </a:pPr>
+            <a:r>
+              <a:rPr lang="en-US" sz="2000" b="1" dirty="0">
+                <a:solidFill>
+                  <a:srgbClr val="FFFFFF"/>
+                </a:solidFill>
+                <a:latin typeface="Arial" pitchFamily="34" charset="0"/>
+                <a:ea typeface="Arial" pitchFamily="34" charset="-122"/>
+                <a:cs typeface="Arial" pitchFamily="34" charset="-120"/>
+              </a:rPr>
+              <a:t>lines of hand-written game code</a:t>
+            </a:r>
+            <a:endParaRPr lang="en-US" sz="2000" dirty="0"/>
+          </a:p>
+        </p:txBody>
+      </p:sp>
+      <p:sp>
+        <p:nvSpPr>
+          <p:cNvPr id="5" name="Text 3"/>
+          <p:cNvSpPr/>
+          <p:nvPr/>
+        </p:nvSpPr>
+        <p:spPr>
+          <a:xfrm>
+            <a:off x="731520" y="3383280"/>
+            <a:ext cx="4572000" cy="548640"/>
+          </a:xfrm>
+          <a:prstGeom prst="rect">
+            <a:avLst/>
+          </a:prstGeom>
+          <a:noFill/>
+          <a:ln/>
+        </p:spPr>
+        <p:txBody>
+          <a:bodyPr wrap="square" rtlCol="0" anchor="ctr"/>
+          <a:lstStyle/>
+          <a:p>
+            <a:pPr indent="0" marL="0">
+              <a:buNone/>
+            </a:pPr>
+            <a:r>
+              <a:rPr lang="en-US" sz="1200" dirty="0">
+                <a:solidFill>
+                  <a:srgbClr val="8899AA"/>
+                </a:solidFill>
+                <a:latin typeface="Arial" pitchFamily="34" charset="0"/>
+                <a:ea typeface="Arial" pitchFamily="34" charset="-122"/>
+                <a:cs typeface="Arial" pitchFamily="34" charset="-120"/>
+              </a:rPr>
+              <a:t>Every line authored by Claude Code under human architectural direction.</a:t>
+            </a:r>
+            <a:endParaRPr lang="en-US" sz="1200" dirty="0"/>
+          </a:p>
+          <a:p>
+            <a:pPr indent="0" marL="0">
+              <a:buNone/>
+            </a:pPr>
+            <a:r>
+              <a:rPr lang="en-US" sz="1200" dirty="0">
+                <a:solidFill>
+                  <a:srgbClr val="8899AA"/>
+                </a:solidFill>
+                <a:latin typeface="Arial" pitchFamily="34" charset="0"/>
+                <a:ea typeface="Arial" pitchFamily="34" charset="-122"/>
+                <a:cs typeface="Arial" pitchFamily="34" charset="-120"/>
+              </a:rPr>
+              <a:t>Not copilot. Not autocomplete. Autonomous development.</a:t>
+            </a:r>
+            <a:endParaRPr lang="en-US" sz="1200" dirty="0"/>
+          </a:p>
+        </p:txBody>
+      </p:sp>
+      <p:sp>
+        <p:nvSpPr>
+          <p:cNvPr id="6" name="Shape 4"/>
+          <p:cNvSpPr/>
+          <p:nvPr/>
+        </p:nvSpPr>
+        <p:spPr>
+          <a:xfrm>
+            <a:off x="5669280" y="914400"/>
+            <a:ext cx="3017520" cy="594360"/>
           </a:xfrm>
           <a:prstGeom prst="rect">
             <a:avLst/>
@@ -3663,34 +3745,14 @@
       </p:sp>
       <p:sp>
         <p:nvSpPr>
-          <p:cNvPr id="4" name="Shape 2"/>
-          <p:cNvSpPr/>
-          <p:nvPr/>
-        </p:nvSpPr>
-        <p:spPr>
-          <a:xfrm>
-            <a:off x="457200" y="914400"/>
-            <a:ext cx="1965960" cy="54864"/>
-          </a:xfrm>
-          <a:prstGeom prst="rect">
-            <a:avLst/>
-          </a:prstGeom>
-          <a:solidFill>
-            <a:srgbClr val="00D4FF"/>
-          </a:solidFill>
-          <a:ln/>
-        </p:spPr>
-      </p:sp>
-      <p:sp>
-        <p:nvSpPr>
-          <p:cNvPr id="5" name="Text 3"/>
-          <p:cNvSpPr/>
-          <p:nvPr/>
-        </p:nvSpPr>
-        <p:spPr>
-          <a:xfrm>
-            <a:off x="594360" y="1097280"/>
-            <a:ext cx="1691640" cy="411480"/>
+          <p:cNvPr id="7" name="Text 5"/>
+          <p:cNvSpPr/>
+          <p:nvPr/>
+        </p:nvSpPr>
+        <p:spPr>
+          <a:xfrm>
+            <a:off x="5852160" y="960120"/>
+            <a:ext cx="1463040" cy="502920"/>
           </a:xfrm>
           <a:prstGeom prst="rect">
             <a:avLst/>
@@ -3706,30 +3768,30 @@
               <a:buNone/>
             </a:pPr>
             <a:r>
-              <a:rPr lang="en-US" sz="1500" b="1" dirty="0">
-                <a:solidFill>
-                  <a:srgbClr val="FFFFFF"/>
-                </a:solidFill>
-                <a:latin typeface="Arial" pitchFamily="34" charset="0"/>
-                <a:ea typeface="Arial" pitchFamily="34" charset="-122"/>
-                <a:cs typeface="Arial" pitchFamily="34" charset="-120"/>
-              </a:rPr>
-              <a:t>Racing Game</a:t>
-            </a:r>
-            <a:endParaRPr lang="en-US" sz="1500" dirty="0"/>
-          </a:p>
-        </p:txBody>
-      </p:sp>
-      <p:sp>
-        <p:nvSpPr>
-          <p:cNvPr id="6" name="Text 4"/>
-          <p:cNvSpPr/>
-          <p:nvPr/>
-        </p:nvSpPr>
-        <p:spPr>
-          <a:xfrm>
-            <a:off x="594360" y="1554480"/>
-            <a:ext cx="1691640" cy="1371600"/>
+              <a:rPr lang="en-US" sz="2000" b="1" dirty="0">
+                <a:solidFill>
+                  <a:srgbClr val="00D4FF"/>
+                </a:solidFill>
+                <a:latin typeface="Arial Black" pitchFamily="34" charset="0"/>
+                <a:ea typeface="Arial Black" pitchFamily="34" charset="-122"/>
+                <a:cs typeface="Arial Black" pitchFamily="34" charset="-120"/>
+              </a:rPr>
+              <a:t>6 of 6</a:t>
+            </a:r>
+            <a:endParaRPr lang="en-US" sz="2000" dirty="0"/>
+          </a:p>
+        </p:txBody>
+      </p:sp>
+      <p:sp>
+        <p:nvSpPr>
+          <p:cNvPr id="8" name="Text 6"/>
+          <p:cNvSpPr/>
+          <p:nvPr/>
+        </p:nvSpPr>
+        <p:spPr>
+          <a:xfrm>
+            <a:off x="7315200" y="960120"/>
+            <a:ext cx="1280160" cy="502920"/>
           </a:xfrm>
           <a:prstGeom prst="rect">
             <a:avLst/>
@@ -3753,39 +3815,22 @@
                 <a:ea typeface="Arial" pitchFamily="34" charset="-122"/>
                 <a:cs typeface="Arial" pitchFamily="34" charset="-120"/>
               </a:rPr>
-              <a:t>3 tracks, full sound, particles,</a:t>
+              <a:t>Phases completed</a:t>
             </a:r>
             <a:endParaRPr lang="en-US" sz="1100" dirty="0"/>
           </a:p>
-          <a:p>
-            <a:pPr indent="0" marL="0">
-              <a:buNone/>
-            </a:pPr>
-            <a:r>
-              <a:rPr lang="en-US" sz="1100" dirty="0">
-                <a:solidFill>
-                  <a:srgbClr val="8899AA"/>
-                </a:solidFill>
-                <a:latin typeface="Arial" pitchFamily="34" charset="0"/>
-                <a:ea typeface="Arial" pitchFamily="34" charset="-122"/>
-                <a:cs typeface="Arial" pitchFamily="34" charset="-120"/>
-              </a:rPr>
-              <a:t>menus, HUD, pause, replays</a:t>
-            </a:r>
-            <a:endParaRPr lang="en-US" sz="1100" dirty="0"/>
-          </a:p>
-        </p:txBody>
-      </p:sp>
-      <p:sp>
-        <p:nvSpPr>
-          <p:cNvPr id="7" name="Shape 5"/>
-          <p:cNvSpPr/>
-          <p:nvPr/>
-        </p:nvSpPr>
-        <p:spPr>
-          <a:xfrm>
-            <a:off x="2606040" y="914400"/>
-            <a:ext cx="1965960" cy="2286000"/>
+        </p:txBody>
+      </p:sp>
+      <p:sp>
+        <p:nvSpPr>
+          <p:cNvPr id="9" name="Shape 7"/>
+          <p:cNvSpPr/>
+          <p:nvPr/>
+        </p:nvSpPr>
+        <p:spPr>
+          <a:xfrm>
+            <a:off x="5669280" y="1627632"/>
+            <a:ext cx="3017520" cy="594360"/>
           </a:xfrm>
           <a:prstGeom prst="rect">
             <a:avLst/>
@@ -3805,34 +3850,14 @@
       </p:sp>
       <p:sp>
         <p:nvSpPr>
-          <p:cNvPr id="8" name="Shape 6"/>
-          <p:cNvSpPr/>
-          <p:nvPr/>
-        </p:nvSpPr>
-        <p:spPr>
-          <a:xfrm>
-            <a:off x="2606040" y="914400"/>
-            <a:ext cx="1965960" cy="54864"/>
-          </a:xfrm>
-          <a:prstGeom prst="rect">
-            <a:avLst/>
-          </a:prstGeom>
-          <a:solidFill>
-            <a:srgbClr val="00FF88"/>
-          </a:solidFill>
-          <a:ln/>
-        </p:spPr>
-      </p:sp>
-      <p:sp>
-        <p:nvSpPr>
-          <p:cNvPr id="9" name="Text 7"/>
-          <p:cNvSpPr/>
-          <p:nvPr/>
-        </p:nvSpPr>
-        <p:spPr>
-          <a:xfrm>
-            <a:off x="2743200" y="1097280"/>
-            <a:ext cx="1691640" cy="411480"/>
+          <p:cNvPr id="10" name="Text 8"/>
+          <p:cNvSpPr/>
+          <p:nvPr/>
+        </p:nvSpPr>
+        <p:spPr>
+          <a:xfrm>
+            <a:off x="5852160" y="1673352"/>
+            <a:ext cx="1463040" cy="502920"/>
           </a:xfrm>
           <a:prstGeom prst="rect">
             <a:avLst/>
@@ -3848,30 +3873,30 @@
               <a:buNone/>
             </a:pPr>
             <a:r>
-              <a:rPr lang="en-US" sz="1500" b="1" dirty="0">
-                <a:solidFill>
-                  <a:srgbClr val="FFFFFF"/>
-                </a:solidFill>
-                <a:latin typeface="Arial" pitchFamily="34" charset="0"/>
-                <a:ea typeface="Arial" pitchFamily="34" charset="-122"/>
-                <a:cs typeface="Arial" pitchFamily="34" charset="-120"/>
-              </a:rPr>
-              <a:t>Neural Network AI</a:t>
-            </a:r>
-            <a:endParaRPr lang="en-US" sz="1500" dirty="0"/>
-          </a:p>
-        </p:txBody>
-      </p:sp>
-      <p:sp>
-        <p:nvSpPr>
-          <p:cNvPr id="10" name="Text 8"/>
-          <p:cNvSpPr/>
-          <p:nvPr/>
-        </p:nvSpPr>
-        <p:spPr>
-          <a:xfrm>
-            <a:off x="2743200" y="1554480"/>
-            <a:ext cx="1691640" cy="1371600"/>
+              <a:rPr lang="en-US" sz="2000" b="1" dirty="0">
+                <a:solidFill>
+                  <a:srgbClr val="00D4FF"/>
+                </a:solidFill>
+                <a:latin typeface="Arial Black" pitchFamily="34" charset="0"/>
+                <a:ea typeface="Arial Black" pitchFamily="34" charset="-122"/>
+                <a:cs typeface="Arial Black" pitchFamily="34" charset="-120"/>
+              </a:rPr>
+              <a:t>189+</a:t>
+            </a:r>
+            <a:endParaRPr lang="en-US" sz="2000" dirty="0"/>
+          </a:p>
+        </p:txBody>
+      </p:sp>
+      <p:sp>
+        <p:nvSpPr>
+          <p:cNvPr id="11" name="Text 9"/>
+          <p:cNvSpPr/>
+          <p:nvPr/>
+        </p:nvSpPr>
+        <p:spPr>
+          <a:xfrm>
+            <a:off x="7315200" y="1673352"/>
+            <a:ext cx="1280160" cy="502920"/>
           </a:xfrm>
           <a:prstGeom prst="rect">
             <a:avLst/>
@@ -3895,39 +3920,22 @@
                 <a:ea typeface="Arial" pitchFamily="34" charset="-122"/>
                 <a:cs typeface="Arial" pitchFamily="34" charset="-120"/>
               </a:rPr>
-              <a:t>Self-taught driving via RL —</a:t>
+              <a:t>Git commits</a:t>
             </a:r>
             <a:endParaRPr lang="en-US" sz="1100" dirty="0"/>
           </a:p>
-          <a:p>
-            <a:pPr indent="0" marL="0">
-              <a:buNone/>
-            </a:pPr>
-            <a:r>
-              <a:rPr lang="en-US" sz="1100" dirty="0">
-                <a:solidFill>
-                  <a:srgbClr val="8899AA"/>
-                </a:solidFill>
-                <a:latin typeface="Arial" pitchFamily="34" charset="0"/>
-                <a:ea typeface="Arial" pitchFamily="34" charset="-122"/>
-                <a:cs typeface="Arial" pitchFamily="34" charset="-120"/>
-              </a:rPr>
-              <a:t>zero human training data</a:t>
-            </a:r>
-            <a:endParaRPr lang="en-US" sz="1100" dirty="0"/>
-          </a:p>
-        </p:txBody>
-      </p:sp>
-      <p:sp>
-        <p:nvSpPr>
-          <p:cNvPr id="11" name="Shape 9"/>
-          <p:cNvSpPr/>
-          <p:nvPr/>
-        </p:nvSpPr>
-        <p:spPr>
-          <a:xfrm>
-            <a:off x="4754880" y="914400"/>
-            <a:ext cx="1965960" cy="2286000"/>
+        </p:txBody>
+      </p:sp>
+      <p:sp>
+        <p:nvSpPr>
+          <p:cNvPr id="12" name="Shape 10"/>
+          <p:cNvSpPr/>
+          <p:nvPr/>
+        </p:nvSpPr>
+        <p:spPr>
+          <a:xfrm>
+            <a:off x="5669280" y="2340864"/>
+            <a:ext cx="3017520" cy="594360"/>
           </a:xfrm>
           <a:prstGeom prst="rect">
             <a:avLst/>
@@ -3947,34 +3955,14 @@
       </p:sp>
       <p:sp>
         <p:nvSpPr>
-          <p:cNvPr id="12" name="Shape 10"/>
-          <p:cNvSpPr/>
-          <p:nvPr/>
-        </p:nvSpPr>
-        <p:spPr>
-          <a:xfrm>
-            <a:off x="4754880" y="914400"/>
-            <a:ext cx="1965960" cy="54864"/>
-          </a:xfrm>
-          <a:prstGeom prst="rect">
-            <a:avLst/>
-          </a:prstGeom>
-          <a:solidFill>
-            <a:srgbClr val="FFB800"/>
-          </a:solidFill>
-          <a:ln/>
-        </p:spPr>
-      </p:sp>
-      <p:sp>
-        <p:nvSpPr>
           <p:cNvPr id="13" name="Text 11"/>
           <p:cNvSpPr/>
           <p:nvPr/>
         </p:nvSpPr>
         <p:spPr>
           <a:xfrm>
-            <a:off x="4892040" y="1097280"/>
-            <a:ext cx="1691640" cy="411480"/>
+            <a:off x="5852160" y="2386584"/>
+            <a:ext cx="1463040" cy="502920"/>
           </a:xfrm>
           <a:prstGeom prst="rect">
             <a:avLst/>
@@ -3990,17 +3978,17 @@
               <a:buNone/>
             </a:pPr>
             <a:r>
-              <a:rPr lang="en-US" sz="1500" b="1" dirty="0">
-                <a:solidFill>
-                  <a:srgbClr val="FFFFFF"/>
-                </a:solidFill>
-                <a:latin typeface="Arial" pitchFamily="34" charset="0"/>
-                <a:ea typeface="Arial" pitchFamily="34" charset="-122"/>
-                <a:cs typeface="Arial" pitchFamily="34" charset="-120"/>
-              </a:rPr>
-              <a:t>Browser Deployed</a:t>
-            </a:r>
-            <a:endParaRPr lang="en-US" sz="1500" dirty="0"/>
+              <a:rPr lang="en-US" sz="2000" b="1" dirty="0">
+                <a:solidFill>
+                  <a:srgbClr val="00D4FF"/>
+                </a:solidFill>
+                <a:latin typeface="Arial Black" pitchFamily="34" charset="0"/>
+                <a:ea typeface="Arial Black" pitchFamily="34" charset="-122"/>
+                <a:cs typeface="Arial Black" pitchFamily="34" charset="-120"/>
+              </a:rPr>
+              <a:t>389+</a:t>
+            </a:r>
+            <a:endParaRPr lang="en-US" sz="2000" dirty="0"/>
           </a:p>
         </p:txBody>
       </p:sp>
@@ -4012,8 +4000,8 @@
         </p:nvSpPr>
         <p:spPr>
           <a:xfrm>
-            <a:off x="4892040" y="1554480"/>
-            <a:ext cx="1691640" cy="1371600"/>
+            <a:off x="7315200" y="2386584"/>
+            <a:ext cx="1280160" cy="502920"/>
           </a:xfrm>
           <a:prstGeom prst="rect">
             <a:avLst/>
@@ -4037,27 +4025,10 @@
                 <a:ea typeface="Arial" pitchFamily="34" charset="-122"/>
                 <a:cs typeface="Arial" pitchFamily="34" charset="-120"/>
               </a:rPr>
-              <a:t>ONNX inference at 60fps,</a:t>
+              <a:t>Automated tests</a:t>
             </a:r>
             <a:endParaRPr lang="en-US" sz="1100" dirty="0"/>
           </a:p>
-          <a:p>
-            <a:pPr indent="0" marL="0">
-              <a:buNone/>
-            </a:pPr>
-            <a:r>
-              <a:rPr lang="en-US" sz="1100" dirty="0">
-                <a:solidFill>
-                  <a:srgbClr val="8899AA"/>
-                </a:solidFill>
-                <a:latin typeface="Arial" pitchFamily="34" charset="0"/>
-                <a:ea typeface="Arial" pitchFamily="34" charset="-122"/>
-                <a:cs typeface="Arial" pitchFamily="34" charset="-120"/>
-              </a:rPr>
-              <a:t>fully static, zero server</a:t>
-            </a:r>
-            <a:endParaRPr lang="en-US" sz="1100" dirty="0"/>
-          </a:p>
         </p:txBody>
       </p:sp>
       <p:sp>
@@ -4068,8 +4039,8 @@
         </p:nvSpPr>
         <p:spPr>
           <a:xfrm>
-            <a:off x="6903720" y="914400"/>
-            <a:ext cx="1965960" cy="2286000"/>
+            <a:off x="5669280" y="3054096"/>
+            <a:ext cx="3017520" cy="594360"/>
           </a:xfrm>
           <a:prstGeom prst="rect">
             <a:avLst/>
@@ -4089,34 +4060,119 @@
       </p:sp>
       <p:sp>
         <p:nvSpPr>
-          <p:cNvPr id="16" name="Shape 14"/>
-          <p:cNvSpPr/>
-          <p:nvPr/>
-        </p:nvSpPr>
-        <p:spPr>
-          <a:xfrm>
-            <a:off x="6903720" y="914400"/>
-            <a:ext cx="1965960" cy="54864"/>
+          <p:cNvPr id="16" name="Text 14"/>
+          <p:cNvSpPr/>
+          <p:nvPr/>
+        </p:nvSpPr>
+        <p:spPr>
+          <a:xfrm>
+            <a:off x="5852160" y="3099816"/>
+            <a:ext cx="1463040" cy="502920"/>
+          </a:xfrm>
+          <a:prstGeom prst="rect">
+            <a:avLst/>
+          </a:prstGeom>
+          <a:noFill/>
+          <a:ln/>
+        </p:spPr>
+        <p:txBody>
+          <a:bodyPr wrap="square" rtlCol="0" anchor="ctr"/>
+          <a:lstStyle/>
+          <a:p>
+            <a:pPr indent="0" marL="0">
+              <a:buNone/>
+            </a:pPr>
+            <a:r>
+              <a:rPr lang="en-US" sz="2000" b="1" dirty="0">
+                <a:solidFill>
+                  <a:srgbClr val="00D4FF"/>
+                </a:solidFill>
+                <a:latin typeface="Arial Black" pitchFamily="34" charset="0"/>
+                <a:ea typeface="Arial Black" pitchFamily="34" charset="-122"/>
+                <a:cs typeface="Arial Black" pitchFamily="34" charset="-120"/>
+              </a:rPr>
+              <a:t>~3</a:t>
+            </a:r>
+            <a:endParaRPr lang="en-US" sz="2000" dirty="0"/>
+          </a:p>
+        </p:txBody>
+      </p:sp>
+      <p:sp>
+        <p:nvSpPr>
+          <p:cNvPr id="17" name="Text 15"/>
+          <p:cNvSpPr/>
+          <p:nvPr/>
+        </p:nvSpPr>
+        <p:spPr>
+          <a:xfrm>
+            <a:off x="7315200" y="3099816"/>
+            <a:ext cx="1280160" cy="502920"/>
+          </a:xfrm>
+          <a:prstGeom prst="rect">
+            <a:avLst/>
+          </a:prstGeom>
+          <a:noFill/>
+          <a:ln/>
+        </p:spPr>
+        <p:txBody>
+          <a:bodyPr wrap="square" rtlCol="0" anchor="ctr"/>
+          <a:lstStyle/>
+          <a:p>
+            <a:pPr indent="0" marL="0">
+              <a:buNone/>
+            </a:pPr>
+            <a:r>
+              <a:rPr lang="en-US" sz="1100" dirty="0">
+                <a:solidFill>
+                  <a:srgbClr val="8899AA"/>
+                </a:solidFill>
+                <a:latin typeface="Arial" pitchFamily="34" charset="0"/>
+                <a:ea typeface="Arial" pitchFamily="34" charset="-122"/>
+                <a:cs typeface="Arial" pitchFamily="34" charset="-120"/>
+              </a:rPr>
+              <a:t>Build days</a:t>
+            </a:r>
+            <a:endParaRPr lang="en-US" sz="1100" dirty="0"/>
+          </a:p>
+        </p:txBody>
+      </p:sp>
+      <p:sp>
+        <p:nvSpPr>
+          <p:cNvPr id="18" name="Shape 16"/>
+          <p:cNvSpPr/>
+          <p:nvPr/>
+        </p:nvSpPr>
+        <p:spPr>
+          <a:xfrm>
+            <a:off x="5669280" y="3767328"/>
+            <a:ext cx="3017520" cy="594360"/>
           </a:xfrm>
           <a:prstGeom prst="rect">
             <a:avLst/>
           </a:prstGeom>
           <a:solidFill>
-            <a:srgbClr val="A78BFA"/>
+            <a:srgbClr val="141929"/>
           </a:solidFill>
           <a:ln/>
-        </p:spPr>
-      </p:sp>
-      <p:sp>
-        <p:nvSpPr>
-          <p:cNvPr id="17" name="Text 15"/>
-          <p:cNvSpPr/>
-          <p:nvPr/>
-        </p:nvSpPr>
-        <p:spPr>
-          <a:xfrm>
-            <a:off x="7040880" y="1097280"/>
-            <a:ext cx="1691640" cy="411480"/>
+          <a:effectLst>
+            <a:outerShdw sx="100000" sy="100000" kx="0" ky="0" algn="bl" rotWithShape="0" blurRad="101600" dist="38100" dir="8100000">
+              <a:srgbClr val="000000">
+                <a:alpha val="40000"/>
+              </a:srgbClr>
+            </a:outerShdw>
+          </a:effectLst>
+        </p:spPr>
+      </p:sp>
+      <p:sp>
+        <p:nvSpPr>
+          <p:cNvPr id="19" name="Text 17"/>
+          <p:cNvSpPr/>
+          <p:nvPr/>
+        </p:nvSpPr>
+        <p:spPr>
+          <a:xfrm>
+            <a:off x="5852160" y="3813048"/>
+            <a:ext cx="1463040" cy="502920"/>
           </a:xfrm>
           <a:prstGeom prst="rect">
             <a:avLst/>
@@ -4132,30 +4188,30 @@
               <a:buNone/>
             </a:pPr>
             <a:r>
-              <a:rPr lang="en-US" sz="1500" b="1" dirty="0">
-                <a:solidFill>
-                  <a:srgbClr val="FFFFFF"/>
-                </a:solidFill>
-                <a:latin typeface="Arial" pitchFamily="34" charset="0"/>
-                <a:ea typeface="Arial" pitchFamily="34" charset="-122"/>
-                <a:cs typeface="Arial" pitchFamily="34" charset="-120"/>
-              </a:rPr>
-              <a:t>AI vs Human</a:t>
-            </a:r>
-            <a:endParaRPr lang="en-US" sz="1500" dirty="0"/>
-          </a:p>
-        </p:txBody>
-      </p:sp>
-      <p:sp>
-        <p:nvSpPr>
-          <p:cNvPr id="18" name="Text 16"/>
-          <p:cNvSpPr/>
-          <p:nvPr/>
-        </p:nvSpPr>
-        <p:spPr>
-          <a:xfrm>
-            <a:off x="7040880" y="1554480"/>
-            <a:ext cx="1691640" cy="1371600"/>
+              <a:rPr lang="en-US" sz="2000" b="1" dirty="0">
+                <a:solidFill>
+                  <a:srgbClr val="00D4FF"/>
+                </a:solidFill>
+                <a:latin typeface="Arial Black" pitchFamily="34" charset="0"/>
+                <a:ea typeface="Arial Black" pitchFamily="34" charset="-122"/>
+                <a:cs typeface="Arial Black" pitchFamily="34" charset="-120"/>
+              </a:rPr>
+              <a:t>10,497</a:t>
+            </a:r>
+            <a:endParaRPr lang="en-US" sz="2000" dirty="0"/>
+          </a:p>
+        </p:txBody>
+      </p:sp>
+      <p:sp>
+        <p:nvSpPr>
+          <p:cNvPr id="20" name="Text 18"/>
+          <p:cNvSpPr/>
+          <p:nvPr/>
+        </p:nvSpPr>
+        <p:spPr>
+          <a:xfrm>
+            <a:off x="7315200" y="3813048"/>
+            <a:ext cx="1280160" cy="502920"/>
           </a:xfrm>
           <a:prstGeom prst="rect">
             <a:avLst/>
@@ -4179,152 +4235,9 @@
                 <a:ea typeface="Arial" pitchFamily="34" charset="-122"/>
                 <a:cs typeface="Arial" pitchFamily="34" charset="-120"/>
               </a:rPr>
-              <a:t>Race against your own creation.</a:t>
+              <a:t>Lines of code</a:t>
             </a:r>
             <a:endParaRPr lang="en-US" sz="1100" dirty="0"/>
-          </a:p>
-          <a:p>
-            <a:pPr indent="0" marL="0">
-              <a:buNone/>
-            </a:pPr>
-            <a:r>
-              <a:rPr lang="en-US" sz="1100" dirty="0">
-                <a:solidFill>
-                  <a:srgbClr val="8899AA"/>
-                </a:solidFill>
-                <a:latin typeface="Arial" pitchFamily="34" charset="0"/>
-                <a:ea typeface="Arial" pitchFamily="34" charset="-122"/>
-                <a:cs typeface="Arial" pitchFamily="34" charset="-120"/>
-              </a:rPr>
-              <a:t>Head-to-head with grace period.</a:t>
-            </a:r>
-            <a:endParaRPr lang="en-US" sz="1100" dirty="0"/>
-          </a:p>
-        </p:txBody>
-      </p:sp>
-      <p:sp>
-        <p:nvSpPr>
-          <p:cNvPr id="19" name="Shape 17"/>
-          <p:cNvSpPr/>
-          <p:nvPr/>
-        </p:nvSpPr>
-        <p:spPr>
-          <a:xfrm>
-            <a:off x="731520" y="3566160"/>
-            <a:ext cx="7680960" cy="502920"/>
-          </a:xfrm>
-          <a:prstGeom prst="roundRect">
-            <a:avLst>
-              <a:gd name="adj" fmla="val 14545"/>
-            </a:avLst>
-          </a:prstGeom>
-          <a:solidFill>
-            <a:srgbClr val="0D1B2A"/>
-          </a:solidFill>
-          <a:ln w="12700">
-            <a:solidFill>
-              <a:srgbClr val="00D4FF"/>
-            </a:solidFill>
-            <a:prstDash val="solid"/>
-          </a:ln>
-        </p:spPr>
-      </p:sp>
-      <p:sp>
-        <p:nvSpPr>
-          <p:cNvPr id="20" name="Text 18"/>
-          <p:cNvSpPr/>
-          <p:nvPr/>
-        </p:nvSpPr>
-        <p:spPr>
-          <a:xfrm>
-            <a:off x="914400" y="3611880"/>
-            <a:ext cx="7315200" cy="411480"/>
-          </a:xfrm>
-          <a:prstGeom prst="rect">
-            <a:avLst/>
-          </a:prstGeom>
-          <a:noFill/>
-          <a:ln/>
-        </p:spPr>
-        <p:txBody>
-          <a:bodyPr wrap="square" rtlCol="0" anchor="ctr"/>
-          <a:lstStyle/>
-          <a:p>
-            <a:pPr algn="ctr" indent="0" marL="0">
-              <a:buNone/>
-            </a:pPr>
-            <a:r>
-              <a:rPr lang="en-US" sz="1200" b="1" dirty="0">
-                <a:solidFill>
-                  <a:srgbClr val="00D4FF"/>
-                </a:solidFill>
-                <a:latin typeface="Arial" pitchFamily="34" charset="0"/>
-                <a:ea typeface="Arial" pitchFamily="34" charset="-122"/>
-                <a:cs typeface="Arial" pitchFamily="34" charset="-120"/>
-              </a:rPr>
-              <a:t>PLAY IT LIVE  →  </a:t>
-            </a:r>
-            <a:pPr algn="ctr" indent="0" marL="0">
-              <a:buNone/>
-            </a:pPr>
-            <a:r>
-              <a:rPr lang="en-US" sz="1200" u="sng" dirty="0">
-                <a:solidFill>
-                  <a:srgbClr val="FFFFFF"/>
-                </a:solidFill>
-                <a:latin typeface="Consolas" pitchFamily="34" charset="0"/>
-                <a:ea typeface="Consolas" pitchFamily="34" charset="-122"/>
-                <a:cs typeface="Consolas" pitchFamily="34" charset="-120"/>
-                <a:hlinkClick r:id="rId1" invalidUrl="" action="" tgtFrame="" tooltip="" history="1" highlightClick="0" endSnd="0">
-                  <a:extLst>
-                    <a:ext uri="{A12FA001-AC4F-418D-AE19-62706E023703}">
-                      <ahyp:hlinkClr xmlns:ahyp="http://schemas.microsoft.com/office/drawing/2018/hyperlinkcolor" val="tx"/>
-                    </a:ext>
-                  </a:extLst>
-                </a:hlinkClick>
-              </a:rPr>
-              <a:t>https://top-down-racer-02.vercel.app/</a:t>
-            </a:r>
-            <a:endParaRPr lang="en-US" sz="1200" dirty="0"/>
-          </a:p>
-        </p:txBody>
-      </p:sp>
-      <p:sp>
-        <p:nvSpPr>
-          <p:cNvPr id="21" name="Text 19"/>
-          <p:cNvSpPr/>
-          <p:nvPr/>
-        </p:nvSpPr>
-        <p:spPr>
-          <a:xfrm>
-            <a:off x="731520" y="4297680"/>
-            <a:ext cx="7680960" cy="365760"/>
-          </a:xfrm>
-          <a:prstGeom prst="rect">
-            <a:avLst/>
-          </a:prstGeom>
-          <a:noFill/>
-          <a:ln/>
-        </p:spPr>
-        <p:txBody>
-          <a:bodyPr wrap="square" rtlCol="0" anchor="ctr"/>
-          <a:lstStyle/>
-          <a:p>
-            <a:pPr algn="ctr" indent="0" marL="0">
-              <a:buNone/>
-            </a:pPr>
-            <a:r>
-              <a:rPr lang="en-US" sz="1300" i="1" dirty="0">
-                <a:solidFill>
-                  <a:srgbClr val="00D4FF"/>
-                </a:solidFill>
-                <a:latin typeface="Arial" pitchFamily="34" charset="0"/>
-                <a:ea typeface="Arial" pitchFamily="34" charset="-122"/>
-                <a:cs typeface="Arial" pitchFamily="34" charset="-120"/>
-              </a:rPr>
-              <a:t>The human never writes code. The human makes decisions.</a:t>
-            </a:r>
-            <a:endParaRPr lang="en-US" sz="1300" dirty="0"/>
           </a:p>
         </p:txBody>
       </p:sp>
@@ -4839,7 +4752,7 @@
         </p:nvSpPr>
         <p:spPr>
           <a:xfrm>
-            <a:off x="274320" y="2743200"/>
+            <a:off x="1691640" y="2743200"/>
             <a:ext cx="2651760" cy="1645920"/>
           </a:xfrm>
           <a:prstGeom prst="rect">
@@ -4866,7 +4779,7 @@
         </p:nvSpPr>
         <p:spPr>
           <a:xfrm>
-            <a:off x="411480" y="2926080"/>
+            <a:off x="1828800" y="2926080"/>
             <a:ext cx="2377440" cy="640080"/>
           </a:xfrm>
           <a:prstGeom prst="rect">
@@ -4905,7 +4818,7 @@
         </p:nvSpPr>
         <p:spPr>
           <a:xfrm>
-            <a:off x="411480" y="3566160"/>
+            <a:off x="1828800" y="3566160"/>
             <a:ext cx="2377440" cy="320040"/>
           </a:xfrm>
           <a:prstGeom prst="rect">
@@ -4944,7 +4857,7 @@
         </p:nvSpPr>
         <p:spPr>
           <a:xfrm>
-            <a:off x="411480" y="3886200"/>
+            <a:off x="1828800" y="3886200"/>
             <a:ext cx="2377440" cy="274320"/>
           </a:xfrm>
           <a:prstGeom prst="rect">
@@ -4983,7 +4896,7 @@
         </p:nvSpPr>
         <p:spPr>
           <a:xfrm>
-            <a:off x="3108960" y="2743200"/>
+            <a:off x="4526280" y="2743200"/>
             <a:ext cx="2651760" cy="1645920"/>
           </a:xfrm>
           <a:prstGeom prst="rect">
@@ -5010,7 +4923,7 @@
         </p:nvSpPr>
         <p:spPr>
           <a:xfrm>
-            <a:off x="3246120" y="2926080"/>
+            <a:off x="4663440" y="2926080"/>
             <a:ext cx="2377440" cy="640080"/>
           </a:xfrm>
           <a:prstGeom prst="rect">
@@ -5049,7 +4962,7 @@
         </p:nvSpPr>
         <p:spPr>
           <a:xfrm>
-            <a:off x="3246120" y="3566160"/>
+            <a:off x="4663440" y="3566160"/>
             <a:ext cx="2377440" cy="320040"/>
           </a:xfrm>
           <a:prstGeom prst="rect">
@@ -5088,7 +5001,7 @@
         </p:nvSpPr>
         <p:spPr>
           <a:xfrm>
-            <a:off x="3246120" y="3886200"/>
+            <a:off x="4663440" y="3886200"/>
             <a:ext cx="2377440" cy="274320"/>
           </a:xfrm>
           <a:prstGeom prst="rect">
@@ -5114,150 +5027,6 @@
                 <a:cs typeface="Arial" pitchFamily="34" charset="-120"/>
               </a:rPr>
               <a:t>Never missed</a:t>
-            </a:r>
-            <a:endParaRPr lang="en-US" sz="1000" dirty="0"/>
-          </a:p>
-        </p:txBody>
-      </p:sp>
-      <p:sp>
-        <p:nvSpPr>
-          <p:cNvPr id="23" name="Shape 21"/>
-          <p:cNvSpPr/>
-          <p:nvPr/>
-        </p:nvSpPr>
-        <p:spPr>
-          <a:xfrm>
-            <a:off x="5943600" y="2743200"/>
-            <a:ext cx="2651760" cy="1645920"/>
-          </a:xfrm>
-          <a:prstGeom prst="rect">
-            <a:avLst/>
-          </a:prstGeom>
-          <a:solidFill>
-            <a:srgbClr val="141929"/>
-          </a:solidFill>
-          <a:ln/>
-          <a:effectLst>
-            <a:outerShdw sx="100000" sy="100000" kx="0" ky="0" algn="bl" rotWithShape="0" blurRad="101600" dist="38100" dir="8100000">
-              <a:srgbClr val="000000">
-                <a:alpha val="40000"/>
-              </a:srgbClr>
-            </a:outerShdw>
-          </a:effectLst>
-        </p:spPr>
-      </p:sp>
-      <p:sp>
-        <p:nvSpPr>
-          <p:cNvPr id="24" name="Text 22"/>
-          <p:cNvSpPr/>
-          <p:nvPr/>
-        </p:nvSpPr>
-        <p:spPr>
-          <a:xfrm>
-            <a:off x="6080760" y="2926080"/>
-            <a:ext cx="2377440" cy="640080"/>
-          </a:xfrm>
-          <a:prstGeom prst="rect">
-            <a:avLst/>
-          </a:prstGeom>
-          <a:noFill/>
-          <a:ln/>
-        </p:spPr>
-        <p:txBody>
-          <a:bodyPr wrap="square" rtlCol="0" anchor="ctr"/>
-          <a:lstStyle/>
-          <a:p>
-            <a:pPr algn="ctr" indent="0" marL="0">
-              <a:buNone/>
-            </a:pPr>
-            <a:r>
-              <a:rPr lang="en-US" sz="3200" b="1" dirty="0">
-                <a:solidFill>
-                  <a:srgbClr val="00FF88"/>
-                </a:solidFill>
-                <a:latin typeface="Arial Black" pitchFamily="34" charset="0"/>
-                <a:ea typeface="Arial Black" pitchFamily="34" charset="-122"/>
-                <a:cs typeface="Arial Black" pitchFamily="34" charset="-120"/>
-              </a:rPr>
-              <a:t>$0</a:t>
-            </a:r>
-            <a:endParaRPr lang="en-US" sz="3200" dirty="0"/>
-          </a:p>
-        </p:txBody>
-      </p:sp>
-      <p:sp>
-        <p:nvSpPr>
-          <p:cNvPr id="25" name="Text 23"/>
-          <p:cNvSpPr/>
-          <p:nvPr/>
-        </p:nvSpPr>
-        <p:spPr>
-          <a:xfrm>
-            <a:off x="6080760" y="3566160"/>
-            <a:ext cx="2377440" cy="320040"/>
-          </a:xfrm>
-          <a:prstGeom prst="rect">
-            <a:avLst/>
-          </a:prstGeom>
-          <a:noFill/>
-          <a:ln/>
-        </p:spPr>
-        <p:txBody>
-          <a:bodyPr wrap="square" rtlCol="0" anchor="ctr"/>
-          <a:lstStyle/>
-          <a:p>
-            <a:pPr algn="ctr" indent="0" marL="0">
-              <a:buNone/>
-            </a:pPr>
-            <a:r>
-              <a:rPr lang="en-US" sz="1200" b="1" dirty="0">
-                <a:solidFill>
-                  <a:srgbClr val="FFFFFF"/>
-                </a:solidFill>
-                <a:latin typeface="Arial" pitchFamily="34" charset="0"/>
-                <a:ea typeface="Arial" pitchFamily="34" charset="-122"/>
-                <a:cs typeface="Arial" pitchFamily="34" charset="-120"/>
-              </a:rPr>
-              <a:t>Server cost</a:t>
-            </a:r>
-            <a:endParaRPr lang="en-US" sz="1200" dirty="0"/>
-          </a:p>
-        </p:txBody>
-      </p:sp>
-      <p:sp>
-        <p:nvSpPr>
-          <p:cNvPr id="26" name="Text 24"/>
-          <p:cNvSpPr/>
-          <p:nvPr/>
-        </p:nvSpPr>
-        <p:spPr>
-          <a:xfrm>
-            <a:off x="6080760" y="3886200"/>
-            <a:ext cx="2377440" cy="274320"/>
-          </a:xfrm>
-          <a:prstGeom prst="rect">
-            <a:avLst/>
-          </a:prstGeom>
-          <a:noFill/>
-          <a:ln/>
-        </p:spPr>
-        <p:txBody>
-          <a:bodyPr wrap="square" rtlCol="0" anchor="ctr"/>
-          <a:lstStyle/>
-          <a:p>
-            <a:pPr algn="ctr" indent="0" marL="0">
-              <a:buNone/>
-            </a:pPr>
-            <a:r>
-              <a:rPr lang="en-US" sz="1000" dirty="0">
-                <a:solidFill>
-                  <a:srgbClr val="8899AA"/>
-                </a:solidFill>
-                <a:latin typeface="Arial" pitchFamily="34" charset="0"/>
-                <a:ea typeface="Arial" pitchFamily="34" charset="-122"/>
-                <a:cs typeface="Arial" pitchFamily="34" charset="-120"/>
-              </a:rPr>
-              <a:t>Fully static deployment</a:t>
             </a:r>
             <a:endParaRPr lang="en-US" sz="1000" dirty="0"/>
           </a:p>
@@ -6455,7 +6224,7 @@
                 <a:ea typeface="Arial" pitchFamily="34" charset="-122"/>
                 <a:cs typeface="Arial" pitchFamily="34" charset="-120"/>
               </a:rPr>
-              <a:t>Two-layer decoupled architecture verified across 80+ commits and 6 phases.</a:t>
+              <a:t>Two-layer decoupled architecture verified across 189+ commits and 6 phases.</a:t>
             </a:r>
             <a:endParaRPr lang="en-US" sz="1100" dirty="0"/>
           </a:p>

</xml_diff>

<commit_message>
docs: update README and AI Autonomy Executive Deck
</commit_message>
<xml_diff>
--- a/projects/top-down-racer-02/docs/summary/AI-Autonomy-Executive-Deck.pptx
+++ b/projects/top-down-racer-02/docs/summary/AI-Autonomy-Executive-Deck.pptx
@@ -1709,7 +1709,7 @@
                 <a:ea typeface="Arial Black" pitchFamily="34" charset="-122"/>
                 <a:cs typeface="Arial Black" pitchFamily="34" charset="-120"/>
               </a:rPr>
-              <a:t>AI SDLC AUTONOMY</a:t>
+              <a:t>BEST-IN-CLASS SDLC.</a:t>
             </a:r>
             <a:endParaRPr lang="en-US" sz="3600" dirty="0"/>
           </a:p>
@@ -1726,7 +1726,7 @@
                 <a:ea typeface="Arial Black" pitchFamily="34" charset="-122"/>
                 <a:cs typeface="Arial Black" pitchFamily="34" charset="-120"/>
               </a:rPr>
-              <a:t>ISN'T THE FUTURE. </a:t>
+              <a:t>BUILT BY AI. </a:t>
             </a:r>
             <a:pPr indent="0" marL="0">
               <a:buNone/>
@@ -1740,7 +1740,7 @@
                 <a:ea typeface="Arial Black" pitchFamily="34" charset="-122"/>
                 <a:cs typeface="Arial Black" pitchFamily="34" charset="-120"/>
               </a:rPr>
-              <a:t>IT'S NOW.</a:t>
+              <a:t>DIRECTED BY HUMANS.</a:t>
             </a:r>
             <a:endParaRPr lang="en-US" sz="3600" dirty="0"/>
           </a:p>
@@ -1818,7 +1818,7 @@
                 <a:ea typeface="Arial" pitchFamily="34" charset="-122"/>
                 <a:cs typeface="Arial" pitchFamily="34" charset="-120"/>
               </a:rPr>
-              <a:t>A complete racing game + neural network AI opponent built by autonomous AI development.</a:t>
+              <a:t>A complete racing game + neural network AI opponent built through autonomous AI SDLC.</a:t>
             </a:r>
             <a:endParaRPr lang="en-US" sz="1300" dirty="0"/>
           </a:p>
@@ -1835,7 +1835,7 @@
                 <a:ea typeface="Arial" pitchFamily="34" charset="-122"/>
                 <a:cs typeface="Arial" pitchFamily="34" charset="-120"/>
               </a:rPr>
-              <a:t>Zero hand-written game code.</a:t>
+              <a:t>Specification, architecture, planning, code, testing, review, defect prevention, deployment.</a:t>
             </a:r>
             <a:endParaRPr lang="en-US" sz="1300" dirty="0"/>
           </a:p>
@@ -1945,7 +1945,7 @@
                 <a:ea typeface="Arial Black" pitchFamily="34" charset="-122"/>
                 <a:cs typeface="Arial Black" pitchFamily="34" charset="-120"/>
               </a:rPr>
-              <a:t>THIS ISN'T A PROOF OF CONCEPT.</a:t>
+              <a:t>THIS ISN'T JUST AUTONOMOUS.</a:t>
             </a:r>
             <a:endParaRPr lang="en-US" sz="2800" dirty="0"/>
           </a:p>
@@ -1984,7 +1984,7 @@
                 <a:ea typeface="Arial Black" pitchFamily="34" charset="-122"/>
                 <a:cs typeface="Arial Black" pitchFamily="34" charset="-120"/>
               </a:rPr>
-              <a:t>IT'S A PROOF OF PRODUCTION.</a:t>
+              <a:t>IT'S BEST-IN-CLASS.</a:t>
             </a:r>
             <a:endParaRPr lang="en-US" sz="2800" dirty="0"/>
           </a:p>
@@ -2740,7 +2740,7 @@
                 <a:ea typeface="Arial" pitchFamily="34" charset="-122"/>
                 <a:cs typeface="Arial" pitchFamily="34" charset="-120"/>
               </a:rPr>
-              <a:t>Full evidence package available.</a:t>
+              <a:t>7-document evidence package. Every claim verified. The SDLC is the product.</a:t>
             </a:r>
             <a:endParaRPr lang="en-US" sz="1200" dirty="0"/>
           </a:p>
@@ -5097,7 +5097,7 @@
                 <a:ea typeface="Arial" pitchFamily="34" charset="-122"/>
                 <a:cs typeface="Arial" pitchFamily="34" charset="-120"/>
               </a:rPr>
-              <a:t>DEFECT PREVENTION: 15 FOR 15</a:t>
+              <a:t>THE RECEIPTS</a:t>
             </a:r>
             <a:endParaRPr lang="en-US" sz="1400" dirty="0"/>
           </a:p>
@@ -5136,7 +5136,7 @@
                 <a:ea typeface="Arial" pitchFamily="34" charset="-122"/>
                 <a:cs typeface="Arial" pitchFamily="34" charset="-120"/>
               </a:rPr>
-              <a:t>Every pre-execution review caught real bugs. Not theoretical risks — concrete defects.</a:t>
+              <a:t>7-document evidence package proving SDLC rigor across the full lifecycle. Not vibes — verification.</a:t>
             </a:r>
             <a:endParaRPr lang="en-US" sz="1100" dirty="0"/>
           </a:p>
@@ -5144,131 +5144,14 @@
       </p:sp>
       <p:sp>
         <p:nvSpPr>
-          <p:cNvPr id="4" name="Text 2"/>
+          <p:cNvPr id="4" name="Shape 2"/>
           <p:cNvSpPr/>
           <p:nvPr/>
         </p:nvSpPr>
         <p:spPr>
           <a:xfrm>
             <a:off x="731520" y="1097280"/>
-            <a:ext cx="2926080" cy="274320"/>
-          </a:xfrm>
-          <a:prstGeom prst="rect">
-            <a:avLst/>
-          </a:prstGeom>
-          <a:noFill/>
-          <a:ln/>
-        </p:spPr>
-        <p:txBody>
-          <a:bodyPr wrap="square" rtlCol="0" anchor="ctr"/>
-          <a:lstStyle/>
-          <a:p>
-            <a:pPr indent="0" marL="0">
-              <a:buNone/>
-            </a:pPr>
-            <a:r>
-              <a:rPr lang="en-US" sz="1000" b="1" dirty="0">
-                <a:solidFill>
-                  <a:srgbClr val="00D4FF"/>
-                </a:solidFill>
-                <a:latin typeface="Arial" pitchFamily="34" charset="0"/>
-                <a:ea typeface="Arial" pitchFamily="34" charset="-122"/>
-                <a:cs typeface="Arial" pitchFamily="34" charset="-120"/>
-              </a:rPr>
-              <a:t>Bug Caught Before Execution</a:t>
-            </a:r>
-            <a:endParaRPr lang="en-US" sz="1000" dirty="0"/>
-          </a:p>
-        </p:txBody>
-      </p:sp>
-      <p:sp>
-        <p:nvSpPr>
-          <p:cNvPr id="5" name="Text 3"/>
-          <p:cNvSpPr/>
-          <p:nvPr/>
-        </p:nvSpPr>
-        <p:spPr>
-          <a:xfrm>
-            <a:off x="3657600" y="1097280"/>
-            <a:ext cx="1097280" cy="274320"/>
-          </a:xfrm>
-          <a:prstGeom prst="rect">
-            <a:avLst/>
-          </a:prstGeom>
-          <a:noFill/>
-          <a:ln/>
-        </p:spPr>
-        <p:txBody>
-          <a:bodyPr wrap="square" rtlCol="0" anchor="ctr"/>
-          <a:lstStyle/>
-          <a:p>
-            <a:pPr algn="ctr" indent="0" marL="0">
-              <a:buNone/>
-            </a:pPr>
-            <a:r>
-              <a:rPr lang="en-US" sz="1000" b="1" dirty="0">
-                <a:solidFill>
-                  <a:srgbClr val="00D4FF"/>
-                </a:solidFill>
-                <a:latin typeface="Arial" pitchFamily="34" charset="0"/>
-                <a:ea typeface="Arial" pitchFamily="34" charset="-122"/>
-                <a:cs typeface="Arial" pitchFamily="34" charset="-120"/>
-              </a:rPr>
-              <a:t>Severity</a:t>
-            </a:r>
-            <a:endParaRPr lang="en-US" sz="1000" dirty="0"/>
-          </a:p>
-        </p:txBody>
-      </p:sp>
-      <p:sp>
-        <p:nvSpPr>
-          <p:cNvPr id="6" name="Text 4"/>
-          <p:cNvSpPr/>
-          <p:nvPr/>
-        </p:nvSpPr>
-        <p:spPr>
-          <a:xfrm>
-            <a:off x="4754880" y="1097280"/>
-            <a:ext cx="3931920" cy="274320"/>
-          </a:xfrm>
-          <a:prstGeom prst="rect">
-            <a:avLst/>
-          </a:prstGeom>
-          <a:noFill/>
-          <a:ln/>
-        </p:spPr>
-        <p:txBody>
-          <a:bodyPr wrap="square" rtlCol="0" anchor="ctr"/>
-          <a:lstStyle/>
-          <a:p>
-            <a:pPr indent="0" marL="0">
-              <a:buNone/>
-            </a:pPr>
-            <a:r>
-              <a:rPr lang="en-US" sz="1000" b="1" dirty="0">
-                <a:solidFill>
-                  <a:srgbClr val="00D4FF"/>
-                </a:solidFill>
-                <a:latin typeface="Arial" pitchFamily="34" charset="0"/>
-                <a:ea typeface="Arial" pitchFamily="34" charset="-122"/>
-                <a:cs typeface="Arial" pitchFamily="34" charset="-120"/>
-              </a:rPr>
-              <a:t>What Would Have Shipped</a:t>
-            </a:r>
-            <a:endParaRPr lang="en-US" sz="1000" dirty="0"/>
-          </a:p>
-        </p:txBody>
-      </p:sp>
-      <p:sp>
-        <p:nvSpPr>
-          <p:cNvPr id="7" name="Shape 5"/>
-          <p:cNvSpPr/>
-          <p:nvPr/>
-        </p:nvSpPr>
-        <p:spPr>
-          <a:xfrm>
-            <a:off x="731520" y="1417320"/>
-            <a:ext cx="7680960" cy="457200"/>
+            <a:ext cx="7680960" cy="420624"/>
           </a:xfrm>
           <a:prstGeom prst="rect">
             <a:avLst/>
@@ -5281,77 +5164,136 @@
       </p:sp>
       <p:sp>
         <p:nvSpPr>
+          <p:cNvPr id="5" name="Shape 3"/>
+          <p:cNvSpPr/>
+          <p:nvPr/>
+        </p:nvSpPr>
+        <p:spPr>
+          <a:xfrm>
+            <a:off x="731520" y="1097280"/>
+            <a:ext cx="45720" cy="420624"/>
+          </a:xfrm>
+          <a:prstGeom prst="rect">
+            <a:avLst/>
+          </a:prstGeom>
+          <a:solidFill>
+            <a:srgbClr val="00D4FF"/>
+          </a:solidFill>
+          <a:ln/>
+        </p:spPr>
+      </p:sp>
+      <p:sp>
+        <p:nvSpPr>
+          <p:cNvPr id="6" name="Text 4"/>
+          <p:cNvSpPr/>
+          <p:nvPr/>
+        </p:nvSpPr>
+        <p:spPr>
+          <a:xfrm>
+            <a:off x="914400" y="1097280"/>
+            <a:ext cx="365760" cy="420624"/>
+          </a:xfrm>
+          <a:prstGeom prst="rect">
+            <a:avLst/>
+          </a:prstGeom>
+          <a:noFill/>
+          <a:ln/>
+        </p:spPr>
+        <p:txBody>
+          <a:bodyPr wrap="square" rtlCol="0" anchor="ctr"/>
+          <a:lstStyle/>
+          <a:p>
+            <a:pPr indent="0" marL="0">
+              <a:buNone/>
+            </a:pPr>
+            <a:r>
+              <a:rPr lang="en-US" sz="1400" b="1" dirty="0">
+                <a:solidFill>
+                  <a:srgbClr val="00D4FF"/>
+                </a:solidFill>
+                <a:latin typeface="Arial Black" pitchFamily="34" charset="0"/>
+                <a:ea typeface="Arial Black" pitchFamily="34" charset="-122"/>
+                <a:cs typeface="Arial Black" pitchFamily="34" charset="-120"/>
+              </a:rPr>
+              <a:t>0</a:t>
+            </a:r>
+            <a:endParaRPr lang="en-US" sz="1400" dirty="0"/>
+          </a:p>
+        </p:txBody>
+      </p:sp>
+      <p:sp>
+        <p:nvSpPr>
+          <p:cNvPr id="7" name="Text 5"/>
+          <p:cNvSpPr/>
+          <p:nvPr/>
+        </p:nvSpPr>
+        <p:spPr>
+          <a:xfrm>
+            <a:off x="1371600" y="1097280"/>
+            <a:ext cx="2926080" cy="420624"/>
+          </a:xfrm>
+          <a:prstGeom prst="rect">
+            <a:avLst/>
+          </a:prstGeom>
+          <a:noFill/>
+          <a:ln/>
+        </p:spPr>
+        <p:txBody>
+          <a:bodyPr wrap="square" rtlCol="0" anchor="ctr"/>
+          <a:lstStyle/>
+          <a:p>
+            <a:pPr indent="0" marL="0">
+              <a:buNone/>
+            </a:pPr>
+            <a:r>
+              <a:rPr lang="en-US" sz="1100" b="1" dirty="0">
+                <a:solidFill>
+                  <a:srgbClr val="FFFFFF"/>
+                </a:solidFill>
+                <a:latin typeface="Arial" pitchFamily="34" charset="0"/>
+                <a:ea typeface="Arial" pitchFamily="34" charset="-122"/>
+                <a:cs typeface="Arial" pitchFamily="34" charset="-120"/>
+              </a:rPr>
+              <a:t>Executive Summary</a:t>
+            </a:r>
+            <a:endParaRPr lang="en-US" sz="1100" dirty="0"/>
+          </a:p>
+        </p:txBody>
+      </p:sp>
+      <p:sp>
+        <p:nvSpPr>
           <p:cNvPr id="8" name="Text 6"/>
           <p:cNvSpPr/>
           <p:nvPr/>
         </p:nvSpPr>
         <p:spPr>
           <a:xfrm>
-            <a:off x="822960" y="1417320"/>
-            <a:ext cx="2743200" cy="457200"/>
-          </a:xfrm>
-          <a:prstGeom prst="rect">
-            <a:avLst/>
-          </a:prstGeom>
-          <a:noFill/>
-          <a:ln/>
-        </p:spPr>
-        <p:txBody>
-          <a:bodyPr wrap="square" rtlCol="0" anchor="ctr"/>
-          <a:lstStyle/>
-          <a:p>
-            <a:pPr indent="0" marL="0">
-              <a:buNone/>
-            </a:pPr>
-            <a:r>
-              <a:rPr lang="en-US" sz="1100" dirty="0">
-                <a:solidFill>
-                  <a:srgbClr val="FFFFFF"/>
-                </a:solidFill>
-                <a:latin typeface="Arial" pitchFamily="34" charset="0"/>
-                <a:ea typeface="Arial" pitchFamily="34" charset="-122"/>
-                <a:cs typeface="Arial" pitchFamily="34" charset="-120"/>
-              </a:rPr>
-              <a:t>Sparse reward (not dense)</a:t>
-            </a:r>
-            <a:endParaRPr lang="en-US" sz="1100" dirty="0"/>
-          </a:p>
-        </p:txBody>
-      </p:sp>
-      <p:sp>
-        <p:nvSpPr>
-          <p:cNvPr id="9" name="Text 7"/>
-          <p:cNvSpPr/>
-          <p:nvPr/>
-        </p:nvSpPr>
-        <p:spPr>
-          <a:xfrm>
-            <a:off x="3657600" y="1417320"/>
-            <a:ext cx="1097280" cy="457200"/>
-          </a:xfrm>
-          <a:prstGeom prst="rect">
-            <a:avLst/>
-          </a:prstGeom>
-          <a:noFill/>
-          <a:ln/>
-        </p:spPr>
-        <p:txBody>
-          <a:bodyPr wrap="square" rtlCol="0" anchor="ctr"/>
-          <a:lstStyle/>
-          <a:p>
-            <a:pPr algn="ctr" indent="0" marL="0">
-              <a:buNone/>
-            </a:pPr>
-            <a:r>
-              <a:rPr lang="en-US" sz="1000" b="1" dirty="0">
-                <a:solidFill>
-                  <a:srgbClr val="FF4444"/>
-                </a:solidFill>
-                <a:latin typeface="Arial" pitchFamily="34" charset="0"/>
-                <a:ea typeface="Arial" pitchFamily="34" charset="-122"/>
-                <a:cs typeface="Arial" pitchFamily="34" charset="-120"/>
-              </a:rPr>
-              <a:t>CRITICAL</a:t>
+            <a:off x="4389120" y="1097280"/>
+            <a:ext cx="3840480" cy="420624"/>
+          </a:xfrm>
+          <a:prstGeom prst="rect">
+            <a:avLst/>
+          </a:prstGeom>
+          <a:noFill/>
+          <a:ln/>
+        </p:spPr>
+        <p:txBody>
+          <a:bodyPr wrap="square" rtlCol="0" anchor="ctr"/>
+          <a:lstStyle/>
+          <a:p>
+            <a:pPr indent="0" marL="0">
+              <a:buNone/>
+            </a:pPr>
+            <a:r>
+              <a:rPr lang="en-US" sz="1000" dirty="0">
+                <a:solidFill>
+                  <a:srgbClr val="8899AA"/>
+                </a:solidFill>
+                <a:latin typeface="Arial" pitchFamily="34" charset="0"/>
+                <a:ea typeface="Arial" pitchFamily="34" charset="-122"/>
+                <a:cs typeface="Arial" pitchFamily="34" charset="-120"/>
+              </a:rPr>
+              <a:t>Full project overview</a:t>
             </a:r>
             <a:endParaRPr lang="en-US" sz="1000" dirty="0"/>
           </a:p>
@@ -5359,53 +5301,14 @@
       </p:sp>
       <p:sp>
         <p:nvSpPr>
-          <p:cNvPr id="10" name="Text 8"/>
-          <p:cNvSpPr/>
-          <p:nvPr/>
-        </p:nvSpPr>
-        <p:spPr>
-          <a:xfrm>
-            <a:off x="4846320" y="1417320"/>
-            <a:ext cx="3474720" cy="457200"/>
-          </a:xfrm>
-          <a:prstGeom prst="rect">
-            <a:avLst/>
-          </a:prstGeom>
-          <a:noFill/>
-          <a:ln/>
-        </p:spPr>
-        <p:txBody>
-          <a:bodyPr wrap="square" rtlCol="0" anchor="ctr"/>
-          <a:lstStyle/>
-          <a:p>
-            <a:pPr indent="0" marL="0">
-              <a:buNone/>
-            </a:pPr>
-            <a:r>
-              <a:rPr lang="en-US" sz="1100" dirty="0">
-                <a:solidFill>
-                  <a:srgbClr val="8899AA"/>
-                </a:solidFill>
-                <a:latin typeface="Arial" pitchFamily="34" charset="0"/>
-                <a:ea typeface="Arial" pitchFamily="34" charset="-122"/>
-                <a:cs typeface="Arial" pitchFamily="34" charset="-120"/>
-              </a:rPr>
-              <a:t>AI training completely fails</a:t>
-            </a:r>
-            <a:endParaRPr lang="en-US" sz="1100" dirty="0"/>
-          </a:p>
-        </p:txBody>
-      </p:sp>
-      <p:sp>
-        <p:nvSpPr>
-          <p:cNvPr id="11" name="Shape 9"/>
-          <p:cNvSpPr/>
-          <p:nvPr/>
-        </p:nvSpPr>
-        <p:spPr>
-          <a:xfrm>
-            <a:off x="731520" y="1920240"/>
-            <a:ext cx="7680960" cy="457200"/>
+          <p:cNvPr id="9" name="Shape 7"/>
+          <p:cNvSpPr/>
+          <p:nvPr/>
+        </p:nvSpPr>
+        <p:spPr>
+          <a:xfrm>
+            <a:off x="731520" y="1554480"/>
+            <a:ext cx="7680960" cy="420624"/>
           </a:xfrm>
           <a:prstGeom prst="rect">
             <a:avLst/>
@@ -5418,30 +5321,89 @@
       </p:sp>
       <p:sp>
         <p:nvSpPr>
+          <p:cNvPr id="10" name="Shape 8"/>
+          <p:cNvSpPr/>
+          <p:nvPr/>
+        </p:nvSpPr>
+        <p:spPr>
+          <a:xfrm>
+            <a:off x="731520" y="1554480"/>
+            <a:ext cx="45720" cy="420624"/>
+          </a:xfrm>
+          <a:prstGeom prst="rect">
+            <a:avLst/>
+          </a:prstGeom>
+          <a:solidFill>
+            <a:srgbClr val="00FF88"/>
+          </a:solidFill>
+          <a:ln/>
+        </p:spPr>
+      </p:sp>
+      <p:sp>
+        <p:nvSpPr>
+          <p:cNvPr id="11" name="Text 9"/>
+          <p:cNvSpPr/>
+          <p:nvPr/>
+        </p:nvSpPr>
+        <p:spPr>
+          <a:xfrm>
+            <a:off x="914400" y="1554480"/>
+            <a:ext cx="365760" cy="420624"/>
+          </a:xfrm>
+          <a:prstGeom prst="rect">
+            <a:avLst/>
+          </a:prstGeom>
+          <a:noFill/>
+          <a:ln/>
+        </p:spPr>
+        <p:txBody>
+          <a:bodyPr wrap="square" rtlCol="0" anchor="ctr"/>
+          <a:lstStyle/>
+          <a:p>
+            <a:pPr indent="0" marL="0">
+              <a:buNone/>
+            </a:pPr>
+            <a:r>
+              <a:rPr lang="en-US" sz="1400" b="1" dirty="0">
+                <a:solidFill>
+                  <a:srgbClr val="00FF88"/>
+                </a:solidFill>
+                <a:latin typeface="Arial Black" pitchFamily="34" charset="0"/>
+                <a:ea typeface="Arial Black" pitchFamily="34" charset="-122"/>
+                <a:cs typeface="Arial Black" pitchFamily="34" charset="-120"/>
+              </a:rPr>
+              <a:t>1</a:t>
+            </a:r>
+            <a:endParaRPr lang="en-US" sz="1400" dirty="0"/>
+          </a:p>
+        </p:txBody>
+      </p:sp>
+      <p:sp>
+        <p:nvSpPr>
           <p:cNvPr id="12" name="Text 10"/>
           <p:cNvSpPr/>
           <p:nvPr/>
         </p:nvSpPr>
         <p:spPr>
           <a:xfrm>
-            <a:off x="822960" y="1920240"/>
-            <a:ext cx="2743200" cy="457200"/>
-          </a:xfrm>
-          <a:prstGeom prst="rect">
-            <a:avLst/>
-          </a:prstGeom>
-          <a:noFill/>
-          <a:ln/>
-        </p:spPr>
-        <p:txBody>
-          <a:bodyPr wrap="square" rtlCol="0" anchor="ctr"/>
-          <a:lstStyle/>
-          <a:p>
-            <a:pPr indent="0" marL="0">
-              <a:buNone/>
-            </a:pPr>
-            <a:r>
-              <a:rPr lang="en-US" sz="1100" dirty="0">
+            <a:off x="1371600" y="1554480"/>
+            <a:ext cx="2926080" cy="420624"/>
+          </a:xfrm>
+          <a:prstGeom prst="rect">
+            <a:avLst/>
+          </a:prstGeom>
+          <a:noFill/>
+          <a:ln/>
+        </p:spPr>
+        <p:txBody>
+          <a:bodyPr wrap="square" rtlCol="0" anchor="ctr"/>
+          <a:lstStyle/>
+          <a:p>
+            <a:pPr indent="0" marL="0">
+              <a:buNone/>
+            </a:pPr>
+            <a:r>
+              <a:rPr lang="en-US" sz="1100" b="1" dirty="0">
                 <a:solidFill>
                   <a:srgbClr val="FFFFFF"/>
                 </a:solidFill>
@@ -5449,7 +5411,7 @@
                 <a:ea typeface="Arial" pitchFamily="34" charset="-122"/>
                 <a:cs typeface="Arial" pitchFamily="34" charset="-120"/>
               </a:rPr>
-              <a:t>Speed bonus 37× too high</a:t>
+              <a:t>Architecture Evidence</a:t>
             </a:r>
             <a:endParaRPr lang="en-US" sz="1100" dirty="0"/>
           </a:p>
@@ -5463,32 +5425,32 @@
         </p:nvSpPr>
         <p:spPr>
           <a:xfrm>
-            <a:off x="3657600" y="1920240"/>
-            <a:ext cx="1097280" cy="457200"/>
-          </a:xfrm>
-          <a:prstGeom prst="rect">
-            <a:avLst/>
-          </a:prstGeom>
-          <a:noFill/>
-          <a:ln/>
-        </p:spPr>
-        <p:txBody>
-          <a:bodyPr wrap="square" rtlCol="0" anchor="ctr"/>
-          <a:lstStyle/>
-          <a:p>
-            <a:pPr algn="ctr" indent="0" marL="0">
-              <a:buNone/>
-            </a:pPr>
-            <a:r>
-              <a:rPr lang="en-US" sz="1000" b="1" dirty="0">
-                <a:solidFill>
-                  <a:srgbClr val="FF4444"/>
-                </a:solidFill>
-                <a:latin typeface="Arial" pitchFamily="34" charset="0"/>
-                <a:ea typeface="Arial" pitchFamily="34" charset="-122"/>
-                <a:cs typeface="Arial" pitchFamily="34" charset="-120"/>
-              </a:rPr>
-              <a:t>CRITICAL</a:t>
+            <a:off x="4389120" y="1554480"/>
+            <a:ext cx="3840480" cy="420624"/>
+          </a:xfrm>
+          <a:prstGeom prst="rect">
+            <a:avLst/>
+          </a:prstGeom>
+          <a:noFill/>
+          <a:ln/>
+        </p:spPr>
+        <p:txBody>
+          <a:bodyPr wrap="square" rtlCol="0" anchor="ctr"/>
+          <a:lstStyle/>
+          <a:p>
+            <a:pPr indent="0" marL="0">
+              <a:buNone/>
+            </a:pPr>
+            <a:r>
+              <a:rPr lang="en-US" sz="1000" dirty="0">
+                <a:solidFill>
+                  <a:srgbClr val="8899AA"/>
+                </a:solidFill>
+                <a:latin typeface="Arial" pitchFamily="34" charset="0"/>
+                <a:ea typeface="Arial" pitchFamily="34" charset="-122"/>
+                <a:cs typeface="Arial" pitchFamily="34" charset="-120"/>
+              </a:rPr>
+              <a:t>0 boundary violations</a:t>
             </a:r>
             <a:endParaRPr lang="en-US" sz="1000" dirty="0"/>
           </a:p>
@@ -5496,53 +5458,14 @@
       </p:sp>
       <p:sp>
         <p:nvSpPr>
-          <p:cNvPr id="14" name="Text 12"/>
-          <p:cNvSpPr/>
-          <p:nvPr/>
-        </p:nvSpPr>
-        <p:spPr>
-          <a:xfrm>
-            <a:off x="4846320" y="1920240"/>
-            <a:ext cx="3474720" cy="457200"/>
-          </a:xfrm>
-          <a:prstGeom prst="rect">
-            <a:avLst/>
-          </a:prstGeom>
-          <a:noFill/>
-          <a:ln/>
-        </p:spPr>
-        <p:txBody>
-          <a:bodyPr wrap="square" rtlCol="0" anchor="ctr"/>
-          <a:lstStyle/>
-          <a:p>
-            <a:pPr indent="0" marL="0">
-              <a:buNone/>
-            </a:pPr>
-            <a:r>
-              <a:rPr lang="en-US" sz="1100" dirty="0">
-                <a:solidFill>
-                  <a:srgbClr val="8899AA"/>
-                </a:solidFill>
-                <a:latin typeface="Arial" pitchFamily="34" charset="0"/>
-                <a:ea typeface="Arial" pitchFamily="34" charset="-122"/>
-                <a:cs typeface="Arial" pitchFamily="34" charset="-120"/>
-              </a:rPr>
-              <a:t>AI spins in circles, never races</a:t>
-            </a:r>
-            <a:endParaRPr lang="en-US" sz="1100" dirty="0"/>
-          </a:p>
-        </p:txBody>
-      </p:sp>
-      <p:sp>
-        <p:nvSpPr>
-          <p:cNvPr id="15" name="Shape 13"/>
-          <p:cNvSpPr/>
-          <p:nvPr/>
-        </p:nvSpPr>
-        <p:spPr>
-          <a:xfrm>
-            <a:off x="731520" y="2423160"/>
-            <a:ext cx="7680960" cy="457200"/>
+          <p:cNvPr id="14" name="Shape 12"/>
+          <p:cNvSpPr/>
+          <p:nvPr/>
+        </p:nvSpPr>
+        <p:spPr>
+          <a:xfrm>
+            <a:off x="731520" y="2011680"/>
+            <a:ext cx="7680960" cy="420624"/>
           </a:xfrm>
           <a:prstGeom prst="rect">
             <a:avLst/>
@@ -5555,30 +5478,89 @@
       </p:sp>
       <p:sp>
         <p:nvSpPr>
+          <p:cNvPr id="15" name="Shape 13"/>
+          <p:cNvSpPr/>
+          <p:nvPr/>
+        </p:nvSpPr>
+        <p:spPr>
+          <a:xfrm>
+            <a:off x="731520" y="2011680"/>
+            <a:ext cx="45720" cy="420624"/>
+          </a:xfrm>
+          <a:prstGeom prst="rect">
+            <a:avLst/>
+          </a:prstGeom>
+          <a:solidFill>
+            <a:srgbClr val="FFB800"/>
+          </a:solidFill>
+          <a:ln/>
+        </p:spPr>
+      </p:sp>
+      <p:sp>
+        <p:nvSpPr>
           <p:cNvPr id="16" name="Text 14"/>
           <p:cNvSpPr/>
           <p:nvPr/>
         </p:nvSpPr>
         <p:spPr>
           <a:xfrm>
-            <a:off x="822960" y="2423160"/>
-            <a:ext cx="2743200" cy="457200"/>
-          </a:xfrm>
-          <a:prstGeom prst="rect">
-            <a:avLst/>
-          </a:prstGeom>
-          <a:noFill/>
-          <a:ln/>
-        </p:spPr>
-        <p:txBody>
-          <a:bodyPr wrap="square" rtlCol="0" anchor="ctr"/>
-          <a:lstStyle/>
-          <a:p>
-            <a:pPr indent="0" marL="0">
-              <a:buNone/>
-            </a:pPr>
-            <a:r>
-              <a:rPr lang="en-US" sz="1100" dirty="0">
+            <a:off x="914400" y="2011680"/>
+            <a:ext cx="365760" cy="420624"/>
+          </a:xfrm>
+          <a:prstGeom prst="rect">
+            <a:avLst/>
+          </a:prstGeom>
+          <a:noFill/>
+          <a:ln/>
+        </p:spPr>
+        <p:txBody>
+          <a:bodyPr wrap="square" rtlCol="0" anchor="ctr"/>
+          <a:lstStyle/>
+          <a:p>
+            <a:pPr indent="0" marL="0">
+              <a:buNone/>
+            </a:pPr>
+            <a:r>
+              <a:rPr lang="en-US" sz="1400" b="1" dirty="0">
+                <a:solidFill>
+                  <a:srgbClr val="FFB800"/>
+                </a:solidFill>
+                <a:latin typeface="Arial Black" pitchFamily="34" charset="0"/>
+                <a:ea typeface="Arial Black" pitchFamily="34" charset="-122"/>
+                <a:cs typeface="Arial Black" pitchFamily="34" charset="-120"/>
+              </a:rPr>
+              <a:t>2</a:t>
+            </a:r>
+            <a:endParaRPr lang="en-US" sz="1400" dirty="0"/>
+          </a:p>
+        </p:txBody>
+      </p:sp>
+      <p:sp>
+        <p:nvSpPr>
+          <p:cNvPr id="17" name="Text 15"/>
+          <p:cNvSpPr/>
+          <p:nvPr/>
+        </p:nvSpPr>
+        <p:spPr>
+          <a:xfrm>
+            <a:off x="1371600" y="2011680"/>
+            <a:ext cx="2926080" cy="420624"/>
+          </a:xfrm>
+          <a:prstGeom prst="rect">
+            <a:avLst/>
+          </a:prstGeom>
+          <a:noFill/>
+          <a:ln/>
+        </p:spPr>
+        <p:txBody>
+          <a:bodyPr wrap="square" rtlCol="0" anchor="ctr"/>
+          <a:lstStyle/>
+          <a:p>
+            <a:pPr indent="0" marL="0">
+              <a:buNone/>
+            </a:pPr>
+            <a:r>
+              <a:rPr lang="en-US" sz="1100" b="1" dirty="0">
                 <a:solidFill>
                   <a:srgbClr val="FFFFFF"/>
                 </a:solidFill>
@@ -5586,7 +5568,7 @@
                 <a:ea typeface="Arial" pitchFamily="34" charset="-122"/>
                 <a:cs typeface="Arial" pitchFamily="34" charset="-120"/>
               </a:rPr>
-              <a:t>VecNorm case mismatch</a:t>
+              <a:t>Requirements Traceability</a:t>
             </a:r>
             <a:endParaRPr lang="en-US" sz="1100" dirty="0"/>
           </a:p>
@@ -5594,38 +5576,38 @@
       </p:sp>
       <p:sp>
         <p:nvSpPr>
-          <p:cNvPr id="17" name="Text 15"/>
-          <p:cNvSpPr/>
-          <p:nvPr/>
-        </p:nvSpPr>
-        <p:spPr>
-          <a:xfrm>
-            <a:off x="3657600" y="2423160"/>
-            <a:ext cx="1097280" cy="457200"/>
-          </a:xfrm>
-          <a:prstGeom prst="rect">
-            <a:avLst/>
-          </a:prstGeom>
-          <a:noFill/>
-          <a:ln/>
-        </p:spPr>
-        <p:txBody>
-          <a:bodyPr wrap="square" rtlCol="0" anchor="ctr"/>
-          <a:lstStyle/>
-          <a:p>
-            <a:pPr algn="ctr" indent="0" marL="0">
-              <a:buNone/>
-            </a:pPr>
-            <a:r>
-              <a:rPr lang="en-US" sz="1000" b="1" dirty="0">
-                <a:solidFill>
-                  <a:srgbClr val="FF4444"/>
-                </a:solidFill>
-                <a:latin typeface="Arial" pitchFamily="34" charset="0"/>
-                <a:ea typeface="Arial" pitchFamily="34" charset="-122"/>
-                <a:cs typeface="Arial" pitchFamily="34" charset="-120"/>
-              </a:rPr>
-              <a:t>CRITICAL</a:t>
+          <p:cNvPr id="18" name="Text 16"/>
+          <p:cNvSpPr/>
+          <p:nvPr/>
+        </p:nvSpPr>
+        <p:spPr>
+          <a:xfrm>
+            <a:off x="4389120" y="2011680"/>
+            <a:ext cx="3840480" cy="420624"/>
+          </a:xfrm>
+          <a:prstGeom prst="rect">
+            <a:avLst/>
+          </a:prstGeom>
+          <a:noFill/>
+          <a:ln/>
+        </p:spPr>
+        <p:txBody>
+          <a:bodyPr wrap="square" rtlCol="0" anchor="ctr"/>
+          <a:lstStyle/>
+          <a:p>
+            <a:pPr indent="0" marL="0">
+              <a:buNone/>
+            </a:pPr>
+            <a:r>
+              <a:rPr lang="en-US" sz="1000" dirty="0">
+                <a:solidFill>
+                  <a:srgbClr val="8899AA"/>
+                </a:solidFill>
+                <a:latin typeface="Arial" pitchFamily="34" charset="0"/>
+                <a:ea typeface="Arial" pitchFamily="34" charset="-122"/>
+                <a:cs typeface="Arial" pitchFamily="34" charset="-120"/>
+              </a:rPr>
+              <a:t>78 traced items, 100% coverage</a:t>
             </a:r>
             <a:endParaRPr lang="en-US" sz="1000" dirty="0"/>
           </a:p>
@@ -5633,53 +5615,14 @@
       </p:sp>
       <p:sp>
         <p:nvSpPr>
-          <p:cNvPr id="18" name="Text 16"/>
-          <p:cNvSpPr/>
-          <p:nvPr/>
-        </p:nvSpPr>
-        <p:spPr>
-          <a:xfrm>
-            <a:off x="4846320" y="2423160"/>
-            <a:ext cx="3474720" cy="457200"/>
-          </a:xfrm>
-          <a:prstGeom prst="rect">
-            <a:avLst/>
-          </a:prstGeom>
-          <a:noFill/>
-          <a:ln/>
-        </p:spPr>
-        <p:txBody>
-          <a:bodyPr wrap="square" rtlCol="0" anchor="ctr"/>
-          <a:lstStyle/>
-          <a:p>
-            <a:pPr indent="0" marL="0">
-              <a:buNone/>
-            </a:pPr>
-            <a:r>
-              <a:rPr lang="en-US" sz="1100" dirty="0">
-                <a:solidFill>
-                  <a:srgbClr val="8899AA"/>
-                </a:solidFill>
-                <a:latin typeface="Arial" pitchFamily="34" charset="0"/>
-                <a:ea typeface="Arial" pitchFamily="34" charset="-122"/>
-                <a:cs typeface="Arial" pitchFamily="34" charset="-120"/>
-              </a:rPr>
-              <a:t>All inference returns NaN</a:t>
-            </a:r>
-            <a:endParaRPr lang="en-US" sz="1100" dirty="0"/>
-          </a:p>
-        </p:txBody>
-      </p:sp>
-      <p:sp>
-        <p:nvSpPr>
           <p:cNvPr id="19" name="Shape 17"/>
           <p:cNvSpPr/>
           <p:nvPr/>
         </p:nvSpPr>
         <p:spPr>
           <a:xfrm>
-            <a:off x="731520" y="2926080"/>
-            <a:ext cx="7680960" cy="457200"/>
+            <a:off x="731520" y="2468880"/>
+            <a:ext cx="7680960" cy="420624"/>
           </a:xfrm>
           <a:prstGeom prst="rect">
             <a:avLst/>
@@ -5692,30 +5635,89 @@
       </p:sp>
       <p:sp>
         <p:nvSpPr>
-          <p:cNvPr id="20" name="Text 18"/>
-          <p:cNvSpPr/>
-          <p:nvPr/>
-        </p:nvSpPr>
-        <p:spPr>
-          <a:xfrm>
-            <a:off x="822960" y="2926080"/>
-            <a:ext cx="2743200" cy="457200"/>
-          </a:xfrm>
-          <a:prstGeom prst="rect">
-            <a:avLst/>
-          </a:prstGeom>
-          <a:noFill/>
-          <a:ln/>
-        </p:spPr>
-        <p:txBody>
-          <a:bodyPr wrap="square" rtlCol="0" anchor="ctr"/>
-          <a:lstStyle/>
-          <a:p>
-            <a:pPr indent="0" marL="0">
-              <a:buNone/>
-            </a:pPr>
-            <a:r>
-              <a:rPr lang="en-US" sz="1100" dirty="0">
+          <p:cNvPr id="20" name="Shape 18"/>
+          <p:cNvSpPr/>
+          <p:nvPr/>
+        </p:nvSpPr>
+        <p:spPr>
+          <a:xfrm>
+            <a:off x="731520" y="2468880"/>
+            <a:ext cx="45720" cy="420624"/>
+          </a:xfrm>
+          <a:prstGeom prst="rect">
+            <a:avLst/>
+          </a:prstGeom>
+          <a:solidFill>
+            <a:srgbClr val="A78BFA"/>
+          </a:solidFill>
+          <a:ln/>
+        </p:spPr>
+      </p:sp>
+      <p:sp>
+        <p:nvSpPr>
+          <p:cNvPr id="21" name="Text 19"/>
+          <p:cNvSpPr/>
+          <p:nvPr/>
+        </p:nvSpPr>
+        <p:spPr>
+          <a:xfrm>
+            <a:off x="914400" y="2468880"/>
+            <a:ext cx="365760" cy="420624"/>
+          </a:xfrm>
+          <a:prstGeom prst="rect">
+            <a:avLst/>
+          </a:prstGeom>
+          <a:noFill/>
+          <a:ln/>
+        </p:spPr>
+        <p:txBody>
+          <a:bodyPr wrap="square" rtlCol="0" anchor="ctr"/>
+          <a:lstStyle/>
+          <a:p>
+            <a:pPr indent="0" marL="0">
+              <a:buNone/>
+            </a:pPr>
+            <a:r>
+              <a:rPr lang="en-US" sz="1400" b="1" dirty="0">
+                <a:solidFill>
+                  <a:srgbClr val="A78BFA"/>
+                </a:solidFill>
+                <a:latin typeface="Arial Black" pitchFamily="34" charset="0"/>
+                <a:ea typeface="Arial Black" pitchFamily="34" charset="-122"/>
+                <a:cs typeface="Arial Black" pitchFamily="34" charset="-120"/>
+              </a:rPr>
+              <a:t>3</a:t>
+            </a:r>
+            <a:endParaRPr lang="en-US" sz="1400" dirty="0"/>
+          </a:p>
+        </p:txBody>
+      </p:sp>
+      <p:sp>
+        <p:nvSpPr>
+          <p:cNvPr id="22" name="Text 20"/>
+          <p:cNvSpPr/>
+          <p:nvPr/>
+        </p:nvSpPr>
+        <p:spPr>
+          <a:xfrm>
+            <a:off x="1371600" y="2468880"/>
+            <a:ext cx="2926080" cy="420624"/>
+          </a:xfrm>
+          <a:prstGeom prst="rect">
+            <a:avLst/>
+          </a:prstGeom>
+          <a:noFill/>
+          <a:ln/>
+        </p:spPr>
+        <p:txBody>
+          <a:bodyPr wrap="square" rtlCol="0" anchor="ctr"/>
+          <a:lstStyle/>
+          <a:p>
+            <a:pPr indent="0" marL="0">
+              <a:buNone/>
+            </a:pPr>
+            <a:r>
+              <a:rPr lang="en-US" sz="1100" b="1" dirty="0">
                 <a:solidFill>
                   <a:srgbClr val="FFFFFF"/>
                 </a:solidFill>
@@ -5723,7 +5725,7 @@
                 <a:ea typeface="Arial" pitchFamily="34" charset="-122"/>
                 <a:cs typeface="Arial" pitchFamily="34" charset="-120"/>
               </a:rPr>
-              <a:t>AI heading 90° wrong</a:t>
+              <a:t>Testing &amp; Defect Prevention</a:t>
             </a:r>
             <a:endParaRPr lang="en-US" sz="1100" dirty="0"/>
           </a:p>
@@ -5731,38 +5733,38 @@
       </p:sp>
       <p:sp>
         <p:nvSpPr>
-          <p:cNvPr id="21" name="Text 19"/>
-          <p:cNvSpPr/>
-          <p:nvPr/>
-        </p:nvSpPr>
-        <p:spPr>
-          <a:xfrm>
-            <a:off x="3657600" y="2926080"/>
-            <a:ext cx="1097280" cy="457200"/>
-          </a:xfrm>
-          <a:prstGeom prst="rect">
-            <a:avLst/>
-          </a:prstGeom>
-          <a:noFill/>
-          <a:ln/>
-        </p:spPr>
-        <p:txBody>
-          <a:bodyPr wrap="square" rtlCol="0" anchor="ctr"/>
-          <a:lstStyle/>
-          <a:p>
-            <a:pPr algn="ctr" indent="0" marL="0">
-              <a:buNone/>
-            </a:pPr>
-            <a:r>
-              <a:rPr lang="en-US" sz="1000" b="1" dirty="0">
-                <a:solidFill>
-                  <a:srgbClr val="FFB800"/>
-                </a:solidFill>
-                <a:latin typeface="Arial" pitchFamily="34" charset="0"/>
-                <a:ea typeface="Arial" pitchFamily="34" charset="-122"/>
-                <a:cs typeface="Arial" pitchFamily="34" charset="-120"/>
-              </a:rPr>
-              <a:t>HIGH</a:t>
+          <p:cNvPr id="23" name="Text 21"/>
+          <p:cNvSpPr/>
+          <p:nvPr/>
+        </p:nvSpPr>
+        <p:spPr>
+          <a:xfrm>
+            <a:off x="4389120" y="2468880"/>
+            <a:ext cx="3840480" cy="420624"/>
+          </a:xfrm>
+          <a:prstGeom prst="rect">
+            <a:avLst/>
+          </a:prstGeom>
+          <a:noFill/>
+          <a:ln/>
+        </p:spPr>
+        <p:txBody>
+          <a:bodyPr wrap="square" rtlCol="0" anchor="ctr"/>
+          <a:lstStyle/>
+          <a:p>
+            <a:pPr indent="0" marL="0">
+              <a:buNone/>
+            </a:pPr>
+            <a:r>
+              <a:rPr lang="en-US" sz="1000" dirty="0">
+                <a:solidFill>
+                  <a:srgbClr val="8899AA"/>
+                </a:solidFill>
+                <a:latin typeface="Arial" pitchFamily="34" charset="0"/>
+                <a:ea typeface="Arial" pitchFamily="34" charset="-122"/>
+                <a:cs typeface="Arial" pitchFamily="34" charset="-120"/>
+              </a:rPr>
+              <a:t>389 tests, 15/15 catches</a:t>
             </a:r>
             <a:endParaRPr lang="en-US" sz="1000" dirty="0"/>
           </a:p>
@@ -5770,53 +5772,14 @@
       </p:sp>
       <p:sp>
         <p:nvSpPr>
-          <p:cNvPr id="22" name="Text 20"/>
-          <p:cNvSpPr/>
-          <p:nvPr/>
-        </p:nvSpPr>
-        <p:spPr>
-          <a:xfrm>
-            <a:off x="4846320" y="2926080"/>
-            <a:ext cx="3474720" cy="457200"/>
-          </a:xfrm>
-          <a:prstGeom prst="rect">
-            <a:avLst/>
-          </a:prstGeom>
-          <a:noFill/>
-          <a:ln/>
-        </p:spPr>
-        <p:txBody>
-          <a:bodyPr wrap="square" rtlCol="0" anchor="ctr"/>
-          <a:lstStyle/>
-          <a:p>
-            <a:pPr indent="0" marL="0">
-              <a:buNone/>
-            </a:pPr>
-            <a:r>
-              <a:rPr lang="en-US" sz="1100" dirty="0">
-                <a:solidFill>
-                  <a:srgbClr val="8899AA"/>
-                </a:solidFill>
-                <a:latin typeface="Arial" pitchFamily="34" charset="0"/>
-                <a:ea typeface="Arial" pitchFamily="34" charset="-122"/>
-                <a:cs typeface="Arial" pitchFamily="34" charset="-120"/>
-              </a:rPr>
-              <a:t>Ghost car drives sideways</a:t>
-            </a:r>
-            <a:endParaRPr lang="en-US" sz="1100" dirty="0"/>
-          </a:p>
-        </p:txBody>
-      </p:sp>
-      <p:sp>
-        <p:nvSpPr>
-          <p:cNvPr id="23" name="Shape 21"/>
-          <p:cNvSpPr/>
-          <p:nvPr/>
-        </p:nvSpPr>
-        <p:spPr>
-          <a:xfrm>
-            <a:off x="731520" y="3429000"/>
-            <a:ext cx="7680960" cy="457200"/>
+          <p:cNvPr id="24" name="Shape 22"/>
+          <p:cNvSpPr/>
+          <p:nvPr/>
+        </p:nvSpPr>
+        <p:spPr>
+          <a:xfrm>
+            <a:off x="731520" y="2926080"/>
+            <a:ext cx="7680960" cy="420624"/>
           </a:xfrm>
           <a:prstGeom prst="rect">
             <a:avLst/>
@@ -5829,30 +5792,89 @@
       </p:sp>
       <p:sp>
         <p:nvSpPr>
-          <p:cNvPr id="24" name="Text 22"/>
-          <p:cNvSpPr/>
-          <p:nvPr/>
-        </p:nvSpPr>
-        <p:spPr>
-          <a:xfrm>
-            <a:off x="822960" y="3429000"/>
-            <a:ext cx="2743200" cy="457200"/>
-          </a:xfrm>
-          <a:prstGeom prst="rect">
-            <a:avLst/>
-          </a:prstGeom>
-          <a:noFill/>
-          <a:ln/>
-        </p:spPr>
-        <p:txBody>
-          <a:bodyPr wrap="square" rtlCol="0" anchor="ctr"/>
-          <a:lstStyle/>
-          <a:p>
-            <a:pPr indent="0" marL="0">
-              <a:buNone/>
-            </a:pPr>
-            <a:r>
-              <a:rPr lang="en-US" sz="1100" dirty="0">
+          <p:cNvPr id="25" name="Shape 23"/>
+          <p:cNvSpPr/>
+          <p:nvPr/>
+        </p:nvSpPr>
+        <p:spPr>
+          <a:xfrm>
+            <a:off x="731520" y="2926080"/>
+            <a:ext cx="45720" cy="420624"/>
+          </a:xfrm>
+          <a:prstGeom prst="rect">
+            <a:avLst/>
+          </a:prstGeom>
+          <a:solidFill>
+            <a:srgbClr val="00D4FF"/>
+          </a:solidFill>
+          <a:ln/>
+        </p:spPr>
+      </p:sp>
+      <p:sp>
+        <p:nvSpPr>
+          <p:cNvPr id="26" name="Text 24"/>
+          <p:cNvSpPr/>
+          <p:nvPr/>
+        </p:nvSpPr>
+        <p:spPr>
+          <a:xfrm>
+            <a:off x="914400" y="2926080"/>
+            <a:ext cx="365760" cy="420624"/>
+          </a:xfrm>
+          <a:prstGeom prst="rect">
+            <a:avLst/>
+          </a:prstGeom>
+          <a:noFill/>
+          <a:ln/>
+        </p:spPr>
+        <p:txBody>
+          <a:bodyPr wrap="square" rtlCol="0" anchor="ctr"/>
+          <a:lstStyle/>
+          <a:p>
+            <a:pPr indent="0" marL="0">
+              <a:buNone/>
+            </a:pPr>
+            <a:r>
+              <a:rPr lang="en-US" sz="1400" b="1" dirty="0">
+                <a:solidFill>
+                  <a:srgbClr val="00D4FF"/>
+                </a:solidFill>
+                <a:latin typeface="Arial Black" pitchFamily="34" charset="0"/>
+                <a:ea typeface="Arial Black" pitchFamily="34" charset="-122"/>
+                <a:cs typeface="Arial Black" pitchFamily="34" charset="-120"/>
+              </a:rPr>
+              <a:t>4</a:t>
+            </a:r>
+            <a:endParaRPr lang="en-US" sz="1400" dirty="0"/>
+          </a:p>
+        </p:txBody>
+      </p:sp>
+      <p:sp>
+        <p:nvSpPr>
+          <p:cNvPr id="27" name="Text 25"/>
+          <p:cNvSpPr/>
+          <p:nvPr/>
+        </p:nvSpPr>
+        <p:spPr>
+          <a:xfrm>
+            <a:off x="1371600" y="2926080"/>
+            <a:ext cx="2926080" cy="420624"/>
+          </a:xfrm>
+          <a:prstGeom prst="rect">
+            <a:avLst/>
+          </a:prstGeom>
+          <a:noFill/>
+          <a:ln/>
+        </p:spPr>
+        <p:txBody>
+          <a:bodyPr wrap="square" rtlCol="0" anchor="ctr"/>
+          <a:lstStyle/>
+          <a:p>
+            <a:pPr indent="0" marL="0">
+              <a:buNone/>
+            </a:pPr>
+            <a:r>
+              <a:rPr lang="en-US" sz="1100" b="1" dirty="0">
                 <a:solidFill>
                   <a:srgbClr val="FFFFFF"/>
                 </a:solidFill>
@@ -5860,7 +5882,7 @@
                 <a:ea typeface="Arial" pitchFamily="34" charset="-122"/>
                 <a:cs typeface="Arial" pitchFamily="34" charset="-120"/>
               </a:rPr>
-              <a:t>Grace ticks during pause</a:t>
+              <a:t>Code Quality Analysis</a:t>
             </a:r>
             <a:endParaRPr lang="en-US" sz="1100" dirty="0"/>
           </a:p>
@@ -5868,38 +5890,38 @@
       </p:sp>
       <p:sp>
         <p:nvSpPr>
-          <p:cNvPr id="25" name="Text 23"/>
-          <p:cNvSpPr/>
-          <p:nvPr/>
-        </p:nvSpPr>
-        <p:spPr>
-          <a:xfrm>
-            <a:off x="3657600" y="3429000"/>
-            <a:ext cx="1097280" cy="457200"/>
-          </a:xfrm>
-          <a:prstGeom prst="rect">
-            <a:avLst/>
-          </a:prstGeom>
-          <a:noFill/>
-          <a:ln/>
-        </p:spPr>
-        <p:txBody>
-          <a:bodyPr wrap="square" rtlCol="0" anchor="ctr"/>
-          <a:lstStyle/>
-          <a:p>
-            <a:pPr algn="ctr" indent="0" marL="0">
-              <a:buNone/>
-            </a:pPr>
-            <a:r>
-              <a:rPr lang="en-US" sz="1000" b="1" dirty="0">
-                <a:solidFill>
-                  <a:srgbClr val="FFB800"/>
-                </a:solidFill>
-                <a:latin typeface="Arial" pitchFamily="34" charset="0"/>
-                <a:ea typeface="Arial" pitchFamily="34" charset="-122"/>
-                <a:cs typeface="Arial" pitchFamily="34" charset="-120"/>
-              </a:rPr>
-              <a:t>HIGH</a:t>
+          <p:cNvPr id="28" name="Text 26"/>
+          <p:cNvSpPr/>
+          <p:nvPr/>
+        </p:nvSpPr>
+        <p:spPr>
+          <a:xfrm>
+            <a:off x="4389120" y="2926080"/>
+            <a:ext cx="3840480" cy="420624"/>
+          </a:xfrm>
+          <a:prstGeom prst="rect">
+            <a:avLst/>
+          </a:prstGeom>
+          <a:noFill/>
+          <a:ln/>
+        </p:spPr>
+        <p:txBody>
+          <a:bodyPr wrap="square" rtlCol="0" anchor="ctr"/>
+          <a:lstStyle/>
+          <a:p>
+            <a:pPr indent="0" marL="0">
+              <a:buNone/>
+            </a:pPr>
+            <a:r>
+              <a:rPr lang="en-US" sz="1000" dirty="0">
+                <a:solidFill>
+                  <a:srgbClr val="8899AA"/>
+                </a:solidFill>
+                <a:latin typeface="Arial" pitchFamily="34" charset="0"/>
+                <a:ea typeface="Arial" pitchFamily="34" charset="-122"/>
+                <a:cs typeface="Arial" pitchFamily="34" charset="-120"/>
+              </a:rPr>
+              <a:t>0 circular deps, strict TS</a:t>
             </a:r>
             <a:endParaRPr lang="en-US" sz="1000" dirty="0"/>
           </a:p>
@@ -5907,53 +5929,14 @@
       </p:sp>
       <p:sp>
         <p:nvSpPr>
-          <p:cNvPr id="26" name="Text 24"/>
-          <p:cNvSpPr/>
-          <p:nvPr/>
-        </p:nvSpPr>
-        <p:spPr>
-          <a:xfrm>
-            <a:off x="4846320" y="3429000"/>
-            <a:ext cx="3474720" cy="457200"/>
-          </a:xfrm>
-          <a:prstGeom prst="rect">
-            <a:avLst/>
-          </a:prstGeom>
-          <a:noFill/>
-          <a:ln/>
-        </p:spPr>
-        <p:txBody>
-          <a:bodyPr wrap="square" rtlCol="0" anchor="ctr"/>
-          <a:lstStyle/>
-          <a:p>
-            <a:pPr indent="0" marL="0">
-              <a:buNone/>
-            </a:pPr>
-            <a:r>
-              <a:rPr lang="en-US" sz="1100" dirty="0">
-                <a:solidFill>
-                  <a:srgbClr val="8899AA"/>
-                </a:solidFill>
-                <a:latin typeface="Arial" pitchFamily="34" charset="0"/>
-                <a:ea typeface="Arial" pitchFamily="34" charset="-122"/>
-                <a:cs typeface="Arial" pitchFamily="34" charset="-120"/>
-              </a:rPr>
-              <a:t>5s window consumed while paused</a:t>
-            </a:r>
-            <a:endParaRPr lang="en-US" sz="1100" dirty="0"/>
-          </a:p>
-        </p:txBody>
-      </p:sp>
-      <p:sp>
-        <p:nvSpPr>
-          <p:cNvPr id="27" name="Shape 25"/>
-          <p:cNvSpPr/>
-          <p:nvPr/>
-        </p:nvSpPr>
-        <p:spPr>
-          <a:xfrm>
-            <a:off x="731520" y="3931920"/>
-            <a:ext cx="7680960" cy="457200"/>
+          <p:cNvPr id="29" name="Shape 27"/>
+          <p:cNvSpPr/>
+          <p:nvPr/>
+        </p:nvSpPr>
+        <p:spPr>
+          <a:xfrm>
+            <a:off x="731520" y="3383280"/>
+            <a:ext cx="7680960" cy="420624"/>
           </a:xfrm>
           <a:prstGeom prst="rect">
             <a:avLst/>
@@ -5966,30 +5949,89 @@
       </p:sp>
       <p:sp>
         <p:nvSpPr>
-          <p:cNvPr id="28" name="Text 26"/>
-          <p:cNvSpPr/>
-          <p:nvPr/>
-        </p:nvSpPr>
-        <p:spPr>
-          <a:xfrm>
-            <a:off x="822960" y="3931920"/>
-            <a:ext cx="2743200" cy="457200"/>
-          </a:xfrm>
-          <a:prstGeom prst="rect">
-            <a:avLst/>
-          </a:prstGeom>
-          <a:noFill/>
-          <a:ln/>
-        </p:spPr>
-        <p:txBody>
-          <a:bodyPr wrap="square" rtlCol="0" anchor="ctr"/>
-          <a:lstStyle/>
-          <a:p>
-            <a:pPr indent="0" marL="0">
-              <a:buNone/>
-            </a:pPr>
-            <a:r>
-              <a:rPr lang="en-US" sz="1100" dirty="0">
+          <p:cNvPr id="30" name="Shape 28"/>
+          <p:cNvSpPr/>
+          <p:nvPr/>
+        </p:nvSpPr>
+        <p:spPr>
+          <a:xfrm>
+            <a:off x="731520" y="3383280"/>
+            <a:ext cx="45720" cy="420624"/>
+          </a:xfrm>
+          <a:prstGeom prst="rect">
+            <a:avLst/>
+          </a:prstGeom>
+          <a:solidFill>
+            <a:srgbClr val="00FF88"/>
+          </a:solidFill>
+          <a:ln/>
+        </p:spPr>
+      </p:sp>
+      <p:sp>
+        <p:nvSpPr>
+          <p:cNvPr id="31" name="Text 29"/>
+          <p:cNvSpPr/>
+          <p:nvPr/>
+        </p:nvSpPr>
+        <p:spPr>
+          <a:xfrm>
+            <a:off x="914400" y="3383280"/>
+            <a:ext cx="365760" cy="420624"/>
+          </a:xfrm>
+          <a:prstGeom prst="rect">
+            <a:avLst/>
+          </a:prstGeom>
+          <a:noFill/>
+          <a:ln/>
+        </p:spPr>
+        <p:txBody>
+          <a:bodyPr wrap="square" rtlCol="0" anchor="ctr"/>
+          <a:lstStyle/>
+          <a:p>
+            <a:pPr indent="0" marL="0">
+              <a:buNone/>
+            </a:pPr>
+            <a:r>
+              <a:rPr lang="en-US" sz="1400" b="1" dirty="0">
+                <a:solidFill>
+                  <a:srgbClr val="00FF88"/>
+                </a:solidFill>
+                <a:latin typeface="Arial Black" pitchFamily="34" charset="0"/>
+                <a:ea typeface="Arial Black" pitchFamily="34" charset="-122"/>
+                <a:cs typeface="Arial Black" pitchFamily="34" charset="-120"/>
+              </a:rPr>
+              <a:t>5</a:t>
+            </a:r>
+            <a:endParaRPr lang="en-US" sz="1400" dirty="0"/>
+          </a:p>
+        </p:txBody>
+      </p:sp>
+      <p:sp>
+        <p:nvSpPr>
+          <p:cNvPr id="32" name="Text 30"/>
+          <p:cNvSpPr/>
+          <p:nvPr/>
+        </p:nvSpPr>
+        <p:spPr>
+          <a:xfrm>
+            <a:off x="1371600" y="3383280"/>
+            <a:ext cx="2926080" cy="420624"/>
+          </a:xfrm>
+          <a:prstGeom prst="rect">
+            <a:avLst/>
+          </a:prstGeom>
+          <a:noFill/>
+          <a:ln/>
+        </p:spPr>
+        <p:txBody>
+          <a:bodyPr wrap="square" rtlCol="0" anchor="ctr"/>
+          <a:lstStyle/>
+          <a:p>
+            <a:pPr indent="0" marL="0">
+              <a:buNone/>
+            </a:pPr>
+            <a:r>
+              <a:rPr lang="en-US" sz="1100" b="1" dirty="0">
                 <a:solidFill>
                   <a:srgbClr val="FFFFFF"/>
                 </a:solidFill>
@@ -5997,7 +6039,7 @@
                 <a:ea typeface="Arial" pitchFamily="34" charset="-122"/>
                 <a:cs typeface="Arial" pitchFamily="34" charset="-120"/>
               </a:rPr>
-              <a:t>WASM tensors not disposed</a:t>
+              <a:t>AI Training Evidence</a:t>
             </a:r>
             <a:endParaRPr lang="en-US" sz="1100" dirty="0"/>
           </a:p>
@@ -6005,14 +6047,367 @@
       </p:sp>
       <p:sp>
         <p:nvSpPr>
-          <p:cNvPr id="29" name="Text 27"/>
-          <p:cNvSpPr/>
-          <p:nvPr/>
-        </p:nvSpPr>
-        <p:spPr>
-          <a:xfrm>
-            <a:off x="3657600" y="3931920"/>
-            <a:ext cx="1097280" cy="457200"/>
+          <p:cNvPr id="33" name="Text 31"/>
+          <p:cNvSpPr/>
+          <p:nvPr/>
+        </p:nvSpPr>
+        <p:spPr>
+          <a:xfrm>
+            <a:off x="4389120" y="3383280"/>
+            <a:ext cx="3840480" cy="420624"/>
+          </a:xfrm>
+          <a:prstGeom prst="rect">
+            <a:avLst/>
+          </a:prstGeom>
+          <a:noFill/>
+          <a:ln/>
+        </p:spPr>
+        <p:txBody>
+          <a:bodyPr wrap="square" rtlCol="0" anchor="ctr"/>
+          <a:lstStyle/>
+          <a:p>
+            <a:pPr indent="0" marL="0">
+              <a:buNone/>
+            </a:pPr>
+            <a:r>
+              <a:rPr lang="en-US" sz="1000" dirty="0">
+                <a:solidFill>
+                  <a:srgbClr val="8899AA"/>
+                </a:solidFill>
+                <a:latin typeface="Arial" pitchFamily="34" charset="0"/>
+                <a:ea typeface="Arial" pitchFamily="34" charset="-122"/>
+                <a:cs typeface="Arial" pitchFamily="34" charset="-120"/>
+              </a:rPr>
+              <a:t>23.7 KB model, 0 tuning iterations</a:t>
+            </a:r>
+            <a:endParaRPr lang="en-US" sz="1000" dirty="0"/>
+          </a:p>
+        </p:txBody>
+      </p:sp>
+      <p:sp>
+        <p:nvSpPr>
+          <p:cNvPr id="34" name="Shape 32"/>
+          <p:cNvSpPr/>
+          <p:nvPr/>
+        </p:nvSpPr>
+        <p:spPr>
+          <a:xfrm>
+            <a:off x="731520" y="3840480"/>
+            <a:ext cx="7680960" cy="420624"/>
+          </a:xfrm>
+          <a:prstGeom prst="rect">
+            <a:avLst/>
+          </a:prstGeom>
+          <a:solidFill>
+            <a:srgbClr val="141929"/>
+          </a:solidFill>
+          <a:ln/>
+        </p:spPr>
+      </p:sp>
+      <p:sp>
+        <p:nvSpPr>
+          <p:cNvPr id="35" name="Shape 33"/>
+          <p:cNvSpPr/>
+          <p:nvPr/>
+        </p:nvSpPr>
+        <p:spPr>
+          <a:xfrm>
+            <a:off x="731520" y="3840480"/>
+            <a:ext cx="45720" cy="420624"/>
+          </a:xfrm>
+          <a:prstGeom prst="rect">
+            <a:avLst/>
+          </a:prstGeom>
+          <a:solidFill>
+            <a:srgbClr val="FFB800"/>
+          </a:solidFill>
+          <a:ln/>
+        </p:spPr>
+      </p:sp>
+      <p:sp>
+        <p:nvSpPr>
+          <p:cNvPr id="36" name="Text 34"/>
+          <p:cNvSpPr/>
+          <p:nvPr/>
+        </p:nvSpPr>
+        <p:spPr>
+          <a:xfrm>
+            <a:off x="914400" y="3840480"/>
+            <a:ext cx="365760" cy="420624"/>
+          </a:xfrm>
+          <a:prstGeom prst="rect">
+            <a:avLst/>
+          </a:prstGeom>
+          <a:noFill/>
+          <a:ln/>
+        </p:spPr>
+        <p:txBody>
+          <a:bodyPr wrap="square" rtlCol="0" anchor="ctr"/>
+          <a:lstStyle/>
+          <a:p>
+            <a:pPr indent="0" marL="0">
+              <a:buNone/>
+            </a:pPr>
+            <a:r>
+              <a:rPr lang="en-US" sz="1400" b="1" dirty="0">
+                <a:solidFill>
+                  <a:srgbClr val="FFB800"/>
+                </a:solidFill>
+                <a:latin typeface="Arial Black" pitchFamily="34" charset="0"/>
+                <a:ea typeface="Arial Black" pitchFamily="34" charset="-122"/>
+                <a:cs typeface="Arial Black" pitchFamily="34" charset="-120"/>
+              </a:rPr>
+              <a:t>6</a:t>
+            </a:r>
+            <a:endParaRPr lang="en-US" sz="1400" dirty="0"/>
+          </a:p>
+        </p:txBody>
+      </p:sp>
+      <p:sp>
+        <p:nvSpPr>
+          <p:cNvPr id="37" name="Text 35"/>
+          <p:cNvSpPr/>
+          <p:nvPr/>
+        </p:nvSpPr>
+        <p:spPr>
+          <a:xfrm>
+            <a:off x="1371600" y="3840480"/>
+            <a:ext cx="2926080" cy="420624"/>
+          </a:xfrm>
+          <a:prstGeom prst="rect">
+            <a:avLst/>
+          </a:prstGeom>
+          <a:noFill/>
+          <a:ln/>
+        </p:spPr>
+        <p:txBody>
+          <a:bodyPr wrap="square" rtlCol="0" anchor="ctr"/>
+          <a:lstStyle/>
+          <a:p>
+            <a:pPr indent="0" marL="0">
+              <a:buNone/>
+            </a:pPr>
+            <a:r>
+              <a:rPr lang="en-US" sz="1100" b="1" dirty="0">
+                <a:solidFill>
+                  <a:srgbClr val="FFFFFF"/>
+                </a:solidFill>
+                <a:latin typeface="Arial" pitchFamily="34" charset="0"/>
+                <a:ea typeface="Arial" pitchFamily="34" charset="-122"/>
+                <a:cs typeface="Arial" pitchFamily="34" charset="-120"/>
+              </a:rPr>
+              <a:t>Process &amp; Workflow</a:t>
+            </a:r>
+            <a:endParaRPr lang="en-US" sz="1100" dirty="0"/>
+          </a:p>
+        </p:txBody>
+      </p:sp>
+      <p:sp>
+        <p:nvSpPr>
+          <p:cNvPr id="38" name="Text 36"/>
+          <p:cNvSpPr/>
+          <p:nvPr/>
+        </p:nvSpPr>
+        <p:spPr>
+          <a:xfrm>
+            <a:off x="4389120" y="3840480"/>
+            <a:ext cx="3840480" cy="420624"/>
+          </a:xfrm>
+          <a:prstGeom prst="rect">
+            <a:avLst/>
+          </a:prstGeom>
+          <a:noFill/>
+          <a:ln/>
+        </p:spPr>
+        <p:txBody>
+          <a:bodyPr wrap="square" rtlCol="0" anchor="ctr"/>
+          <a:lstStyle/>
+          <a:p>
+            <a:pPr indent="0" marL="0">
+              <a:buNone/>
+            </a:pPr>
+            <a:r>
+              <a:rPr lang="en-US" sz="1000" dirty="0">
+                <a:solidFill>
+                  <a:srgbClr val="8899AA"/>
+                </a:solidFill>
+                <a:latin typeface="Arial" pitchFamily="34" charset="0"/>
+                <a:ea typeface="Arial" pitchFamily="34" charset="-122"/>
+                <a:cs typeface="Arial" pitchFamily="34" charset="-120"/>
+              </a:rPr>
+              <a:t>47 decisions, 11 learnings</a:t>
+            </a:r>
+            <a:endParaRPr lang="en-US" sz="1000" dirty="0"/>
+          </a:p>
+        </p:txBody>
+      </p:sp>
+      <p:sp>
+        <p:nvSpPr>
+          <p:cNvPr id="39" name="Shape 37"/>
+          <p:cNvSpPr/>
+          <p:nvPr/>
+        </p:nvSpPr>
+        <p:spPr>
+          <a:xfrm>
+            <a:off x="731520" y="4297680"/>
+            <a:ext cx="7680960" cy="420624"/>
+          </a:xfrm>
+          <a:prstGeom prst="rect">
+            <a:avLst/>
+          </a:prstGeom>
+          <a:solidFill>
+            <a:srgbClr val="141929"/>
+          </a:solidFill>
+          <a:ln/>
+        </p:spPr>
+      </p:sp>
+      <p:sp>
+        <p:nvSpPr>
+          <p:cNvPr id="40" name="Shape 38"/>
+          <p:cNvSpPr/>
+          <p:nvPr/>
+        </p:nvSpPr>
+        <p:spPr>
+          <a:xfrm>
+            <a:off x="731520" y="4297680"/>
+            <a:ext cx="45720" cy="420624"/>
+          </a:xfrm>
+          <a:prstGeom prst="rect">
+            <a:avLst/>
+          </a:prstGeom>
+          <a:solidFill>
+            <a:srgbClr val="A78BFA"/>
+          </a:solidFill>
+          <a:ln/>
+        </p:spPr>
+      </p:sp>
+      <p:sp>
+        <p:nvSpPr>
+          <p:cNvPr id="41" name="Text 39"/>
+          <p:cNvSpPr/>
+          <p:nvPr/>
+        </p:nvSpPr>
+        <p:spPr>
+          <a:xfrm>
+            <a:off x="914400" y="4297680"/>
+            <a:ext cx="365760" cy="420624"/>
+          </a:xfrm>
+          <a:prstGeom prst="rect">
+            <a:avLst/>
+          </a:prstGeom>
+          <a:noFill/>
+          <a:ln/>
+        </p:spPr>
+        <p:txBody>
+          <a:bodyPr wrap="square" rtlCol="0" anchor="ctr"/>
+          <a:lstStyle/>
+          <a:p>
+            <a:pPr indent="0" marL="0">
+              <a:buNone/>
+            </a:pPr>
+            <a:r>
+              <a:rPr lang="en-US" sz="1400" b="1" dirty="0">
+                <a:solidFill>
+                  <a:srgbClr val="A78BFA"/>
+                </a:solidFill>
+                <a:latin typeface="Arial Black" pitchFamily="34" charset="0"/>
+                <a:ea typeface="Arial Black" pitchFamily="34" charset="-122"/>
+                <a:cs typeface="Arial Black" pitchFamily="34" charset="-120"/>
+              </a:rPr>
+              <a:t>7</a:t>
+            </a:r>
+            <a:endParaRPr lang="en-US" sz="1400" dirty="0"/>
+          </a:p>
+        </p:txBody>
+      </p:sp>
+      <p:sp>
+        <p:nvSpPr>
+          <p:cNvPr id="42" name="Text 40"/>
+          <p:cNvSpPr/>
+          <p:nvPr/>
+        </p:nvSpPr>
+        <p:spPr>
+          <a:xfrm>
+            <a:off x="1371600" y="4297680"/>
+            <a:ext cx="2926080" cy="420624"/>
+          </a:xfrm>
+          <a:prstGeom prst="rect">
+            <a:avLst/>
+          </a:prstGeom>
+          <a:noFill/>
+          <a:ln/>
+        </p:spPr>
+        <p:txBody>
+          <a:bodyPr wrap="square" rtlCol="0" anchor="ctr"/>
+          <a:lstStyle/>
+          <a:p>
+            <a:pPr indent="0" marL="0">
+              <a:buNone/>
+            </a:pPr>
+            <a:r>
+              <a:rPr lang="en-US" sz="1100" b="1" dirty="0">
+                <a:solidFill>
+                  <a:srgbClr val="FFFFFF"/>
+                </a:solidFill>
+                <a:latin typeface="Arial" pitchFamily="34" charset="0"/>
+                <a:ea typeface="Arial" pitchFamily="34" charset="-122"/>
+                <a:cs typeface="Arial" pitchFamily="34" charset="-120"/>
+              </a:rPr>
+              <a:t>Build Metrics Dashboard</a:t>
+            </a:r>
+            <a:endParaRPr lang="en-US" sz="1100" dirty="0"/>
+          </a:p>
+        </p:txBody>
+      </p:sp>
+      <p:sp>
+        <p:nvSpPr>
+          <p:cNvPr id="43" name="Text 41"/>
+          <p:cNvSpPr/>
+          <p:nvPr/>
+        </p:nvSpPr>
+        <p:spPr>
+          <a:xfrm>
+            <a:off x="4389120" y="4297680"/>
+            <a:ext cx="3840480" cy="420624"/>
+          </a:xfrm>
+          <a:prstGeom prst="rect">
+            <a:avLst/>
+          </a:prstGeom>
+          <a:noFill/>
+          <a:ln/>
+        </p:spPr>
+        <p:txBody>
+          <a:bodyPr wrap="square" rtlCol="0" anchor="ctr"/>
+          <a:lstStyle/>
+          <a:p>
+            <a:pPr indent="0" marL="0">
+              <a:buNone/>
+            </a:pPr>
+            <a:r>
+              <a:rPr lang="en-US" sz="1000" dirty="0">
+                <a:solidFill>
+                  <a:srgbClr val="8899AA"/>
+                </a:solidFill>
+                <a:latin typeface="Arial" pitchFamily="34" charset="0"/>
+                <a:ea typeface="Arial" pitchFamily="34" charset="-122"/>
+                <a:cs typeface="Arial" pitchFamily="34" charset="-120"/>
+              </a:rPr>
+              <a:t>All metrics visualized</a:t>
+            </a:r>
+            <a:endParaRPr lang="en-US" sz="1000" dirty="0"/>
+          </a:p>
+        </p:txBody>
+      </p:sp>
+      <p:sp>
+        <p:nvSpPr>
+          <p:cNvPr id="44" name="Text 42"/>
+          <p:cNvSpPr/>
+          <p:nvPr/>
+        </p:nvSpPr>
+        <p:spPr>
+          <a:xfrm>
+            <a:off x="731520" y="4892040"/>
+            <a:ext cx="7680960" cy="320040"/>
           </a:xfrm>
           <a:prstGeom prst="rect">
             <a:avLst/>
@@ -6028,84 +6423,6 @@
               <a:buNone/>
             </a:pPr>
             <a:r>
-              <a:rPr lang="en-US" sz="1000" b="1" dirty="0">
-                <a:solidFill>
-                  <a:srgbClr val="00FF88"/>
-                </a:solidFill>
-                <a:latin typeface="Arial" pitchFamily="34" charset="0"/>
-                <a:ea typeface="Arial" pitchFamily="34" charset="-122"/>
-                <a:cs typeface="Arial" pitchFamily="34" charset="-120"/>
-              </a:rPr>
-              <a:t>MEDIUM</a:t>
-            </a:r>
-            <a:endParaRPr lang="en-US" sz="1000" dirty="0"/>
-          </a:p>
-        </p:txBody>
-      </p:sp>
-      <p:sp>
-        <p:nvSpPr>
-          <p:cNvPr id="30" name="Text 28"/>
-          <p:cNvSpPr/>
-          <p:nvPr/>
-        </p:nvSpPr>
-        <p:spPr>
-          <a:xfrm>
-            <a:off x="4846320" y="3931920"/>
-            <a:ext cx="3474720" cy="457200"/>
-          </a:xfrm>
-          <a:prstGeom prst="rect">
-            <a:avLst/>
-          </a:prstGeom>
-          <a:noFill/>
-          <a:ln/>
-        </p:spPr>
-        <p:txBody>
-          <a:bodyPr wrap="square" rtlCol="0" anchor="ctr"/>
-          <a:lstStyle/>
-          <a:p>
-            <a:pPr indent="0" marL="0">
-              <a:buNone/>
-            </a:pPr>
-            <a:r>
-              <a:rPr lang="en-US" sz="1100" dirty="0">
-                <a:solidFill>
-                  <a:srgbClr val="8899AA"/>
-                </a:solidFill>
-                <a:latin typeface="Arial" pitchFamily="34" charset="0"/>
-                <a:ea typeface="Arial" pitchFamily="34" charset="-122"/>
-                <a:cs typeface="Arial" pitchFamily="34" charset="-120"/>
-              </a:rPr>
-              <a:t>43 KB/min memory leak</a:t>
-            </a:r>
-            <a:endParaRPr lang="en-US" sz="1100" dirty="0"/>
-          </a:p>
-        </p:txBody>
-      </p:sp>
-      <p:sp>
-        <p:nvSpPr>
-          <p:cNvPr id="31" name="Text 29"/>
-          <p:cNvSpPr/>
-          <p:nvPr/>
-        </p:nvSpPr>
-        <p:spPr>
-          <a:xfrm>
-            <a:off x="731520" y="4617720"/>
-            <a:ext cx="7680960" cy="320040"/>
-          </a:xfrm>
-          <a:prstGeom prst="rect">
-            <a:avLst/>
-          </a:prstGeom>
-          <a:noFill/>
-          <a:ln/>
-        </p:spPr>
-        <p:txBody>
-          <a:bodyPr wrap="square" rtlCol="0" anchor="ctr"/>
-          <a:lstStyle/>
-          <a:p>
-            <a:pPr algn="ctr" indent="0" marL="0">
-              <a:buNone/>
-            </a:pPr>
-            <a:r>
               <a:rPr lang="en-US" sz="1100" i="1" dirty="0">
                 <a:solidFill>
                   <a:srgbClr val="00D4FF"/>
@@ -6114,7 +6431,7 @@
                 <a:ea typeface="Arial" pitchFamily="34" charset="-122"/>
                 <a:cs typeface="Arial" pitchFamily="34" charset="-120"/>
               </a:rPr>
-              <a:t>10–12 specialized research agents review every plan before a single line of code is written.</a:t>
+              <a:t>Every claim backed by automated evidence, not assertions. Best-in-class SDLC demands best-in-class proof.</a:t>
             </a:r>
             <a:endParaRPr lang="en-US" sz="1100" dirty="0"/>
           </a:p>
@@ -8013,7 +8330,7 @@
                 <a:ea typeface="Arial" pitchFamily="34" charset="-122"/>
                 <a:cs typeface="Arial" pitchFamily="34" charset="-120"/>
               </a:rPr>
-              <a:t>NOT VIBES. ENGINEERING.</a:t>
+              <a:t>BEST-IN-CLASS SDLC. RUN BY AI.</a:t>
             </a:r>
             <a:endParaRPr lang="en-US" sz="1400" dirty="0"/>
           </a:p>
@@ -9116,7 +9433,7 @@
                 <a:ea typeface="Arial" pitchFamily="34" charset="-122"/>
                 <a:cs typeface="Arial" pitchFamily="34" charset="-120"/>
               </a:rPr>
-              <a:t>Context rot eliminated. Task 50 runs at the same quality as Task 1.</a:t>
+              <a:t>Context rot eliminated. Task 189 runs at the same quality as Task 1.</a:t>
             </a:r>
             <a:endParaRPr lang="en-US" sz="1200" dirty="0"/>
           </a:p>
@@ -9155,7 +9472,7 @@
                 <a:ea typeface="Arial" pitchFamily="34" charset="-122"/>
                 <a:cs typeface="Arial" pitchFamily="34" charset="-120"/>
               </a:rPr>
-              <a:t>The human never writes code. The human makes decisions.</a:t>
+              <a:t>Not just autonomous development. Best-in-class SDLC — with the evidence to prove it.</a:t>
             </a:r>
             <a:endParaRPr lang="en-US" sz="1300" dirty="0"/>
           </a:p>

</xml_diff>

<commit_message>
docs: update README and AI autonomy deck, remove Light version
</commit_message>
<xml_diff>
--- a/projects/top-down-racer-02/docs/summary/AI-Autonomy-Executive-Deck.pptx
+++ b/projects/top-down-racer-02/docs/summary/AI-Autonomy-Executive-Deck.pptx
@@ -1490,7 +1490,7 @@
                 <a:latin typeface="Arial" pitchFamily="34" charset="0"/>
                 <a:cs typeface="Arial" pitchFamily="34" charset="-120"/>
               </a:rPr>
-              <a:t>AI SDLC Autonomy isn't the future. It's now </a:t>
+              <a:t xml:space="preserve">AI SDLC Autonomy isn't the future. It's now </a:t>
             </a:r>
             <a:endParaRPr lang="en-US" sz="1800" dirty="0"/>
           </a:p>
@@ -2337,7 +2337,7 @@
                 <a:ea typeface="Arial" pitchFamily="34" charset="-122"/>
                 <a:cs typeface="Arial" pitchFamily="34" charset="-120"/>
               </a:rPr>
-              <a:t>PLAY IT LIVE  →  </a:t>
+              <a:t xml:space="preserve">PLAY IT LIVE  →  </a:t>
             </a:r>
             <a:r>
               <a:rPr lang="en-US" sz="1200" u="sng" dirty="0">
@@ -2583,7 +2583,7 @@
                 <a:ea typeface="Arial" pitchFamily="34" charset="-122"/>
                 <a:cs typeface="Arial" pitchFamily="34" charset="-120"/>
               </a:rPr>
-              <a:t>Every line authored by Claude Code. </a:t>
+              <a:t xml:space="preserve">Every line authored by Claude Code. </a:t>
             </a:r>
           </a:p>
           <a:p>
@@ -2801,7 +2801,7 @@
                 <a:ea typeface="Arial Black" pitchFamily="34" charset="-122"/>
                 <a:cs typeface="Arial Black" pitchFamily="34" charset="-120"/>
               </a:rPr>
-              <a:t>189+</a:t>
+              <a:t>189</a:t>
             </a:r>
             <a:endParaRPr lang="en-US" sz="2000" dirty="0"/>
           </a:p>
@@ -2913,7 +2913,7 @@
                 <a:ea typeface="Arial Black" pitchFamily="34" charset="-122"/>
                 <a:cs typeface="Arial Black" pitchFamily="34" charset="-120"/>
               </a:rPr>
-              <a:t>389+</a:t>
+              <a:t>389</a:t>
             </a:r>
             <a:endParaRPr lang="en-US" sz="2000" dirty="0"/>
           </a:p>
@@ -6052,7 +6052,7 @@
         </p:nvSpPr>
         <p:spPr>
           <a:xfrm>
-            <a:off x="5943600" y="1371600"/>
+            <a:off x="5943600" y="1360170"/>
             <a:ext cx="2743200" cy="502920"/>
           </a:xfrm>
           <a:prstGeom prst="rect">
@@ -6079,7 +6079,7 @@
         </p:nvSpPr>
         <p:spPr>
           <a:xfrm>
-            <a:off x="6035040" y="1371600"/>
+            <a:off x="6035040" y="1360170"/>
             <a:ext cx="731520" cy="502920"/>
           </a:xfrm>
           <a:prstGeom prst="rect">
@@ -6118,7 +6118,7 @@
         </p:nvSpPr>
         <p:spPr>
           <a:xfrm>
-            <a:off x="6858000" y="1371600"/>
+            <a:off x="6858000" y="1360170"/>
             <a:ext cx="1737360" cy="502920"/>
           </a:xfrm>
           <a:prstGeom prst="rect">
@@ -6157,7 +6157,7 @@
         </p:nvSpPr>
         <p:spPr>
           <a:xfrm>
-            <a:off x="5943600" y="1920240"/>
+            <a:off x="5943600" y="1897380"/>
             <a:ext cx="2743200" cy="502920"/>
           </a:xfrm>
           <a:prstGeom prst="rect">
@@ -6184,7 +6184,7 @@
         </p:nvSpPr>
         <p:spPr>
           <a:xfrm>
-            <a:off x="6035040" y="1920240"/>
+            <a:off x="6035040" y="1897380"/>
             <a:ext cx="918210" cy="502920"/>
           </a:xfrm>
           <a:prstGeom prst="rect">
@@ -6223,7 +6223,7 @@
         </p:nvSpPr>
         <p:spPr>
           <a:xfrm>
-            <a:off x="6858000" y="1920240"/>
+            <a:off x="6858000" y="1897380"/>
             <a:ext cx="1737360" cy="502920"/>
           </a:xfrm>
           <a:prstGeom prst="rect">
@@ -6262,7 +6262,7 @@
         </p:nvSpPr>
         <p:spPr>
           <a:xfrm>
-            <a:off x="5943600" y="2468880"/>
+            <a:off x="5943600" y="2434590"/>
             <a:ext cx="2743200" cy="502920"/>
           </a:xfrm>
           <a:prstGeom prst="rect">
@@ -6289,7 +6289,7 @@
         </p:nvSpPr>
         <p:spPr>
           <a:xfrm>
-            <a:off x="6035040" y="2468880"/>
+            <a:off x="6035040" y="2434590"/>
             <a:ext cx="731520" cy="502920"/>
           </a:xfrm>
           <a:prstGeom prst="rect">
@@ -6328,7 +6328,7 @@
         </p:nvSpPr>
         <p:spPr>
           <a:xfrm>
-            <a:off x="6858000" y="2468880"/>
+            <a:off x="6858000" y="2434590"/>
             <a:ext cx="1737360" cy="502920"/>
           </a:xfrm>
           <a:prstGeom prst="rect">
@@ -6367,7 +6367,7 @@
         </p:nvSpPr>
         <p:spPr>
           <a:xfrm>
-            <a:off x="5943600" y="3017520"/>
+            <a:off x="5943600" y="2971800"/>
             <a:ext cx="2743200" cy="502920"/>
           </a:xfrm>
           <a:prstGeom prst="rect">
@@ -6394,7 +6394,7 @@
         </p:nvSpPr>
         <p:spPr>
           <a:xfrm>
-            <a:off x="6035040" y="3017520"/>
+            <a:off x="6035040" y="2971800"/>
             <a:ext cx="731520" cy="502920"/>
           </a:xfrm>
           <a:prstGeom prst="rect">
@@ -6433,7 +6433,7 @@
         </p:nvSpPr>
         <p:spPr>
           <a:xfrm>
-            <a:off x="6858000" y="3017520"/>
+            <a:off x="6858000" y="2971800"/>
             <a:ext cx="1737360" cy="502920"/>
           </a:xfrm>
           <a:prstGeom prst="rect">
@@ -9124,7 +9124,7 @@
                 <a:ea typeface="Arial Black" pitchFamily="34" charset="-122"/>
                 <a:cs typeface="Arial Black" pitchFamily="34" charset="-120"/>
               </a:rPr>
-              <a:t>389+</a:t>
+              <a:t>389</a:t>
             </a:r>
             <a:endParaRPr lang="en-US" sz="2000" dirty="0"/>
           </a:p>
@@ -9236,7 +9236,7 @@
                 <a:ea typeface="Arial Black" pitchFamily="34" charset="-122"/>
                 <a:cs typeface="Arial Black" pitchFamily="34" charset="-120"/>
               </a:rPr>
-              <a:t>189+</a:t>
+              <a:t>189</a:t>
             </a:r>
             <a:endParaRPr lang="en-US" sz="2000" dirty="0"/>
           </a:p>
@@ -9796,7 +9796,7 @@
                 <a:ea typeface="Arial" pitchFamily="34" charset="-122"/>
                 <a:cs typeface="Arial" pitchFamily="34" charset="-120"/>
               </a:rPr>
-              <a:t>PLAY IT NOW  →  </a:t>
+              <a:t xml:space="preserve">PLAY IT NOW  →  </a:t>
             </a:r>
             <a:r>
               <a:rPr lang="en-US" sz="1300" u="sng" dirty="0">

</xml_diff>